<commit_message>
Remove broken animations so PowerPoint opens without repair
</commit_message>
<xml_diff>
--- a/Security_Powers_the_Frontier.pptx
+++ b/Security_Powers_the_Frontier.pptx
@@ -11892,389 +11892,6 @@
       </p:transition>
     </mc:Fallback>
   </mc:AlternateContent>
-  <p:timing>
-    <p:tnLst>
-      <p:par>
-        <p:cTn id="1" dur="indefinite" restart="never" nodeType="tmRoot">
-          <p:childTnLst>
-            <p:seq concurrent="1" nextAc="seek">
-              <p:cTn id="2" dur="indefinite" nodeType="mainSeq">
-                <p:childTnLst>
-                  <p:par>
-                    <p:cTn id="3" fill="hold">
-                      <p:stCondLst>
-                        <p:cond delay="indefinite"/>
-                        <p:cond evt="onBegin" delay="0">
-                          <p:tn val="2"/>
-                        </p:cond>
-                      </p:stCondLst>
-                      <p:childTnLst>
-                        <p:par>
-                          <p:cTn id="4" fill="hold">
-                            <p:stCondLst>
-                              <p:cond delay="0"/>
-                            </p:stCondLst>
-                            <p:childTnLst>
-                              <p:par>
-                                <p:cTn id="5" presetID="22" presetClass="entr" presetSubtype="8" fill="hold" grpId="0" nodeType="withEffect" nodePh="1">
-                                  <p:stCondLst>
-                                    <p:cond delay="0"/>
-                                  </p:stCondLst>
-                                  <p:endCondLst>
-                                    <p:cond evt="begin" delay="0">
-                                      <p:tn val="5"/>
-                                    </p:cond>
-                                  </p:endCondLst>
-                                  <p:childTnLst>
-                                    <p:set>
-                                      <p:cBhvr>
-                                        <p:cTn id="6" dur="1" fill="hold">
-                                          <p:stCondLst>
-                                            <p:cond delay="0"/>
-                                          </p:stCondLst>
-                                        </p:cTn>
-                                        <p:tgtEl>
-                                          <p:spTgt spid="2"/>
-                                        </p:tgtEl>
-                                        <p:attrNameLst>
-                                          <p:attrName>style.visibility</p:attrName>
-                                        </p:attrNameLst>
-                                      </p:cBhvr>
-                                      <p:to>
-                                        <p:strVal val="visible"/>
-                                      </p:to>
-                                    </p:set>
-                                    <p:animEffect transition="in" filter="wipe(left)">
-                                      <p:cBhvr>
-                                        <p:cTn id="7" dur="500"/>
-                                        <p:tgtEl>
-                                          <p:spTgt spid="2"/>
-                                        </p:tgtEl>
-                                      </p:cBhvr>
-                                    </p:animEffect>
-                                  </p:childTnLst>
-                                </p:cTn>
-                              </p:par>
-                              <p:par>
-                                <p:cTn id="8" presetID="10" presetClass="entr" presetSubtype="0" fill="hold" grpId="0" nodeType="withEffect">
-                                  <p:stCondLst>
-                                    <p:cond delay="0"/>
-                                  </p:stCondLst>
-                                  <p:childTnLst>
-                                    <p:set>
-                                      <p:cBhvr>
-                                        <p:cTn id="9" dur="1" fill="hold">
-                                          <p:stCondLst>
-                                            <p:cond delay="0"/>
-                                          </p:stCondLst>
-                                        </p:cTn>
-                                        <p:tgtEl>
-                                          <p:spTgt spid="6"/>
-                                        </p:tgtEl>
-                                        <p:attrNameLst>
-                                          <p:attrName>style.visibility</p:attrName>
-                                        </p:attrNameLst>
-                                      </p:cBhvr>
-                                      <p:to>
-                                        <p:strVal val="visible"/>
-                                      </p:to>
-                                    </p:set>
-                                    <p:animEffect transition="in" filter="fade">
-                                      <p:cBhvr>
-                                        <p:cTn id="10" dur="500"/>
-                                        <p:tgtEl>
-                                          <p:spTgt spid="6"/>
-                                        </p:tgtEl>
-                                      </p:cBhvr>
-                                    </p:animEffect>
-                                  </p:childTnLst>
-                                </p:cTn>
-                              </p:par>
-                              <p:par>
-                                <p:cTn id="11" presetID="42" presetClass="path" presetSubtype="0" decel="100000" fill="hold" grpId="1" nodeType="withEffect">
-                                  <p:stCondLst>
-                                    <p:cond delay="0"/>
-                                  </p:stCondLst>
-                                  <p:childTnLst>
-                                    <p:animMotion origin="layout" path="M 2.08333E-7 1.48148E-6 L 2.08333E-7 0.03542 " pathEditMode="relative" rAng="0" ptsTypes="AA">
-                                      <p:cBhvr>
-                                        <p:cTn id="12" dur="700" spd="-100000" fill="hold"/>
-                                        <p:tgtEl>
-                                          <p:spTgt spid="6"/>
-                                        </p:tgtEl>
-                                        <p:attrNameLst>
-                                          <p:attrName>ppt_x</p:attrName>
-                                          <p:attrName>ppt_y</p:attrName>
-                                        </p:attrNameLst>
-                                      </p:cBhvr>
-                                      <p:rCtr x="0" y="1759"/>
-                                    </p:animMotion>
-                                  </p:childTnLst>
-                                </p:cTn>
-                              </p:par>
-                              <p:par>
-                                <p:cTn id="13" presetID="10" presetClass="entr" presetSubtype="0" fill="hold" grpId="0" nodeType="withEffect">
-                                  <p:stCondLst>
-                                    <p:cond delay="100"/>
-                                  </p:stCondLst>
-                                  <p:childTnLst>
-                                    <p:set>
-                                      <p:cBhvr>
-                                        <p:cTn id="14" dur="1" fill="hold">
-                                          <p:stCondLst>
-                                            <p:cond delay="0"/>
-                                          </p:stCondLst>
-                                        </p:cTn>
-                                        <p:tgtEl>
-                                          <p:spTgt spid="60"/>
-                                        </p:tgtEl>
-                                        <p:attrNameLst>
-                                          <p:attrName>style.visibility</p:attrName>
-                                        </p:attrNameLst>
-                                      </p:cBhvr>
-                                      <p:to>
-                                        <p:strVal val="visible"/>
-                                      </p:to>
-                                    </p:set>
-                                    <p:animEffect transition="in" filter="fade">
-                                      <p:cBhvr>
-                                        <p:cTn id="15" dur="500"/>
-                                        <p:tgtEl>
-                                          <p:spTgt spid="60"/>
-                                        </p:tgtEl>
-                                      </p:cBhvr>
-                                    </p:animEffect>
-                                  </p:childTnLst>
-                                </p:cTn>
-                              </p:par>
-                              <p:par>
-                                <p:cTn id="16" presetID="42" presetClass="path" presetSubtype="0" decel="100000" fill="hold" grpId="1" nodeType="withEffect">
-                                  <p:stCondLst>
-                                    <p:cond delay="100"/>
-                                  </p:stCondLst>
-                                  <p:childTnLst>
-                                    <p:animMotion origin="layout" path="M 2.08333E-7 1.48148E-6 L 2.08333E-7 0.03542 " pathEditMode="relative" rAng="0" ptsTypes="AA">
-                                      <p:cBhvr>
-                                        <p:cTn id="17" dur="700" spd="-100000" fill="hold"/>
-                                        <p:tgtEl>
-                                          <p:spTgt spid="60"/>
-                                        </p:tgtEl>
-                                        <p:attrNameLst>
-                                          <p:attrName>ppt_x</p:attrName>
-                                          <p:attrName>ppt_y</p:attrName>
-                                        </p:attrNameLst>
-                                      </p:cBhvr>
-                                      <p:rCtr x="0" y="1759"/>
-                                    </p:animMotion>
-                                  </p:childTnLst>
-                                </p:cTn>
-                              </p:par>
-                              <p:par>
-                                <p:cTn id="18" presetID="10" presetClass="entr" presetSubtype="0" fill="hold" nodeType="withEffect">
-                                  <p:stCondLst>
-                                    <p:cond delay="100"/>
-                                  </p:stCondLst>
-                                  <p:childTnLst>
-                                    <p:set>
-                                      <p:cBhvr>
-                                        <p:cTn id="19" dur="1" fill="hold">
-                                          <p:stCondLst>
-                                            <p:cond delay="0"/>
-                                          </p:stCondLst>
-                                        </p:cTn>
-                                        <p:tgtEl>
-                                          <p:spTgt spid="59"/>
-                                        </p:tgtEl>
-                                        <p:attrNameLst>
-                                          <p:attrName>style.visibility</p:attrName>
-                                        </p:attrNameLst>
-                                      </p:cBhvr>
-                                      <p:to>
-                                        <p:strVal val="visible"/>
-                                      </p:to>
-                                    </p:set>
-                                    <p:animEffect transition="in" filter="fade">
-                                      <p:cBhvr>
-                                        <p:cTn id="20" dur="500"/>
-                                        <p:tgtEl>
-                                          <p:spTgt spid="59"/>
-                                        </p:tgtEl>
-                                      </p:cBhvr>
-                                    </p:animEffect>
-                                  </p:childTnLst>
-                                </p:cTn>
-                              </p:par>
-                              <p:par>
-                                <p:cTn id="21" presetID="42" presetClass="path" presetSubtype="0" decel="100000" fill="hold" nodeType="withEffect">
-                                  <p:stCondLst>
-                                    <p:cond delay="100"/>
-                                  </p:stCondLst>
-                                  <p:childTnLst>
-                                    <p:animMotion origin="layout" path="M 2.08333E-7 1.48148E-6 L 2.08333E-7 0.03542 " pathEditMode="relative" rAng="0" ptsTypes="AA">
-                                      <p:cBhvr>
-                                        <p:cTn id="22" dur="700" spd="-100000" fill="hold"/>
-                                        <p:tgtEl>
-                                          <p:spTgt spid="59"/>
-                                        </p:tgtEl>
-                                        <p:attrNameLst>
-                                          <p:attrName>ppt_x</p:attrName>
-                                          <p:attrName>ppt_y</p:attrName>
-                                        </p:attrNameLst>
-                                      </p:cBhvr>
-                                      <p:rCtr x="0" y="1759"/>
-                                    </p:animMotion>
-                                  </p:childTnLst>
-                                </p:cTn>
-                              </p:par>
-                              <p:par>
-                                <p:cTn id="23" presetID="10" presetClass="entr" presetSubtype="0" fill="hold" nodeType="withEffect">
-                                  <p:stCondLst>
-                                    <p:cond delay="100"/>
-                                  </p:stCondLst>
-                                  <p:childTnLst>
-                                    <p:set>
-                                      <p:cBhvr>
-                                        <p:cTn id="24" dur="1" fill="hold">
-                                          <p:stCondLst>
-                                            <p:cond delay="0"/>
-                                          </p:stCondLst>
-                                        </p:cTn>
-                                        <p:tgtEl>
-                                          <p:spTgt spid="34"/>
-                                        </p:tgtEl>
-                                        <p:attrNameLst>
-                                          <p:attrName>style.visibility</p:attrName>
-                                        </p:attrNameLst>
-                                      </p:cBhvr>
-                                      <p:to>
-                                        <p:strVal val="visible"/>
-                                      </p:to>
-                                    </p:set>
-                                    <p:animEffect transition="in" filter="fade">
-                                      <p:cBhvr>
-                                        <p:cTn id="25" dur="500"/>
-                                        <p:tgtEl>
-                                          <p:spTgt spid="34"/>
-                                        </p:tgtEl>
-                                      </p:cBhvr>
-                                    </p:animEffect>
-                                  </p:childTnLst>
-                                </p:cTn>
-                              </p:par>
-                              <p:par>
-                                <p:cTn id="26" presetID="42" presetClass="path" presetSubtype="0" decel="100000" fill="hold" nodeType="withEffect">
-                                  <p:stCondLst>
-                                    <p:cond delay="100"/>
-                                  </p:stCondLst>
-                                  <p:childTnLst>
-                                    <p:animMotion origin="layout" path="M 2.08333E-7 1.48148E-6 L 2.08333E-7 0.03542 " pathEditMode="relative" rAng="0" ptsTypes="AA">
-                                      <p:cBhvr>
-                                        <p:cTn id="27" dur="700" spd="-100000" fill="hold"/>
-                                        <p:tgtEl>
-                                          <p:spTgt spid="34"/>
-                                        </p:tgtEl>
-                                        <p:attrNameLst>
-                                          <p:attrName>ppt_x</p:attrName>
-                                          <p:attrName>ppt_y</p:attrName>
-                                        </p:attrNameLst>
-                                      </p:cBhvr>
-                                      <p:rCtr x="0" y="1759"/>
-                                    </p:animMotion>
-                                  </p:childTnLst>
-                                </p:cTn>
-                              </p:par>
-                              <p:par>
-                                <p:cTn id="28" presetID="10" presetClass="entr" presetSubtype="0" fill="hold" nodeType="withEffect">
-                                  <p:stCondLst>
-                                    <p:cond delay="100"/>
-                                  </p:stCondLst>
-                                  <p:childTnLst>
-                                    <p:set>
-                                      <p:cBhvr>
-                                        <p:cTn id="29" dur="1" fill="hold">
-                                          <p:stCondLst>
-                                            <p:cond delay="0"/>
-                                          </p:stCondLst>
-                                        </p:cTn>
-                                        <p:tgtEl>
-                                          <p:spTgt spid="38"/>
-                                        </p:tgtEl>
-                                        <p:attrNameLst>
-                                          <p:attrName>style.visibility</p:attrName>
-                                        </p:attrNameLst>
-                                      </p:cBhvr>
-                                      <p:to>
-                                        <p:strVal val="visible"/>
-                                      </p:to>
-                                    </p:set>
-                                    <p:animEffect transition="in" filter="fade">
-                                      <p:cBhvr>
-                                        <p:cTn id="30" dur="500"/>
-                                        <p:tgtEl>
-                                          <p:spTgt spid="38"/>
-                                        </p:tgtEl>
-                                      </p:cBhvr>
-                                    </p:animEffect>
-                                  </p:childTnLst>
-                                </p:cTn>
-                              </p:par>
-                              <p:par>
-                                <p:cTn id="31" presetID="42" presetClass="path" presetSubtype="0" decel="100000" fill="hold" nodeType="withEffect">
-                                  <p:stCondLst>
-                                    <p:cond delay="100"/>
-                                  </p:stCondLst>
-                                  <p:childTnLst>
-                                    <p:animMotion origin="layout" path="M 2.08333E-7 1.48148E-6 L 2.08333E-7 0.03542 " pathEditMode="relative" rAng="0" ptsTypes="AA">
-                                      <p:cBhvr>
-                                        <p:cTn id="32" dur="700" spd="-100000" fill="hold"/>
-                                        <p:tgtEl>
-                                          <p:spTgt spid="38"/>
-                                        </p:tgtEl>
-                                        <p:attrNameLst>
-                                          <p:attrName>ppt_x</p:attrName>
-                                          <p:attrName>ppt_y</p:attrName>
-                                        </p:attrNameLst>
-                                      </p:cBhvr>
-                                      <p:rCtr x="0" y="1759"/>
-                                    </p:animMotion>
-                                  </p:childTnLst>
-                                </p:cTn>
-                              </p:par>
-                            </p:childTnLst>
-                          </p:cTn>
-                        </p:par>
-                      </p:childTnLst>
-                    </p:cTn>
-                  </p:par>
-                </p:childTnLst>
-              </p:cTn>
-              <p:prevCondLst>
-                <p:cond evt="onPrev" delay="0">
-                  <p:tgtEl>
-                    <p:sldTgt/>
-                  </p:tgtEl>
-                </p:cond>
-              </p:prevCondLst>
-              <p:nextCondLst>
-                <p:cond evt="onNext" delay="0">
-                  <p:tgtEl>
-                    <p:sldTgt/>
-                  </p:tgtEl>
-                </p:cond>
-              </p:nextCondLst>
-            </p:seq>
-          </p:childTnLst>
-        </p:cTn>
-      </p:par>
-    </p:tnLst>
-    <p:bldLst>
-      <p:bldP spid="60" grpId="0" animBg="1"/>
-      <p:bldP spid="60" grpId="1" animBg="1"/>
-      <p:bldP spid="2" grpId="0"/>
-      <p:bldP spid="6" grpId="0"/>
-      <p:bldP spid="6" grpId="1"/>
-    </p:bldLst>
-  </p:timing>
 </p:sld>
 </file>
 
@@ -13243,938 +12860,6 @@
       </p:transition>
     </mc:Fallback>
   </mc:AlternateContent>
-  <p:timing>
-    <p:tnLst>
-      <p:par>
-        <p:cTn id="1" dur="indefinite" restart="never" nodeType="tmRoot">
-          <p:childTnLst>
-            <p:seq concurrent="1" nextAc="seek">
-              <p:cTn id="2" dur="indefinite" nodeType="mainSeq">
-                <p:childTnLst>
-                  <p:par>
-                    <p:cTn id="3" fill="hold">
-                      <p:stCondLst>
-                        <p:cond delay="indefinite"/>
-                        <p:cond evt="onBegin" delay="0">
-                          <p:tn val="2"/>
-                        </p:cond>
-                      </p:stCondLst>
-                      <p:childTnLst>
-                        <p:par>
-                          <p:cTn id="4" fill="hold">
-                            <p:stCondLst>
-                              <p:cond delay="0"/>
-                            </p:stCondLst>
-                            <p:childTnLst>
-                              <p:par>
-                                <p:cTn id="5" presetID="10" presetClass="entr" presetSubtype="0" fill="hold" grpId="0" nodeType="withEffect">
-                                  <p:stCondLst>
-                                    <p:cond delay="0"/>
-                                  </p:stCondLst>
-                                  <p:childTnLst>
-                                    <p:set>
-                                      <p:cBhvr>
-                                        <p:cTn id="6" dur="1" fill="hold">
-                                          <p:stCondLst>
-                                            <p:cond delay="0"/>
-                                          </p:stCondLst>
-                                        </p:cTn>
-                                        <p:tgtEl>
-                                          <p:spTgt spid="2"/>
-                                        </p:tgtEl>
-                                        <p:attrNameLst>
-                                          <p:attrName>style.visibility</p:attrName>
-                                        </p:attrNameLst>
-                                      </p:cBhvr>
-                                      <p:to>
-                                        <p:strVal val="visible"/>
-                                      </p:to>
-                                    </p:set>
-                                    <p:animEffect transition="in" filter="fade">
-                                      <p:cBhvr>
-                                        <p:cTn id="7" dur="500"/>
-                                        <p:tgtEl>
-                                          <p:spTgt spid="2"/>
-                                        </p:tgtEl>
-                                      </p:cBhvr>
-                                    </p:animEffect>
-                                  </p:childTnLst>
-                                </p:cTn>
-                              </p:par>
-                              <p:par>
-                                <p:cTn id="8" presetID="42" presetClass="path" presetSubtype="0" decel="100000" fill="hold" grpId="1" nodeType="withEffect">
-                                  <p:stCondLst>
-                                    <p:cond delay="0"/>
-                                  </p:stCondLst>
-                                  <p:childTnLst>
-                                    <p:animMotion origin="layout" path="M 2.08333E-7 1.48148E-6 L 2.08333E-7 0.03542 " pathEditMode="relative" rAng="0" ptsTypes="AA">
-                                      <p:cBhvr>
-                                        <p:cTn id="9" dur="700" spd="-100000" fill="hold"/>
-                                        <p:tgtEl>
-                                          <p:spTgt spid="2"/>
-                                        </p:tgtEl>
-                                        <p:attrNameLst>
-                                          <p:attrName>ppt_x</p:attrName>
-                                          <p:attrName>ppt_y</p:attrName>
-                                        </p:attrNameLst>
-                                      </p:cBhvr>
-                                      <p:rCtr x="0" y="1759"/>
-                                    </p:animMotion>
-                                  </p:childTnLst>
-                                </p:cTn>
-                              </p:par>
-                              <p:par>
-                                <p:cTn id="10" presetID="10" presetClass="entr" presetSubtype="0" fill="hold" grpId="0" nodeType="withEffect">
-                                  <p:stCondLst>
-                                    <p:cond delay="100"/>
-                                  </p:stCondLst>
-                                  <p:childTnLst>
-                                    <p:set>
-                                      <p:cBhvr>
-                                        <p:cTn id="11" dur="1" fill="hold">
-                                          <p:stCondLst>
-                                            <p:cond delay="0"/>
-                                          </p:stCondLst>
-                                        </p:cTn>
-                                        <p:tgtEl>
-                                          <p:spTgt spid="18"/>
-                                        </p:tgtEl>
-                                        <p:attrNameLst>
-                                          <p:attrName>style.visibility</p:attrName>
-                                        </p:attrNameLst>
-                                      </p:cBhvr>
-                                      <p:to>
-                                        <p:strVal val="visible"/>
-                                      </p:to>
-                                    </p:set>
-                                    <p:animEffect transition="in" filter="fade">
-                                      <p:cBhvr>
-                                        <p:cTn id="12" dur="500"/>
-                                        <p:tgtEl>
-                                          <p:spTgt spid="18"/>
-                                        </p:tgtEl>
-                                      </p:cBhvr>
-                                    </p:animEffect>
-                                  </p:childTnLst>
-                                </p:cTn>
-                              </p:par>
-                              <p:par>
-                                <p:cTn id="13" presetID="42" presetClass="path" presetSubtype="0" decel="100000" fill="hold" grpId="1" nodeType="withEffect">
-                                  <p:stCondLst>
-                                    <p:cond delay="100"/>
-                                  </p:stCondLst>
-                                  <p:childTnLst>
-                                    <p:animMotion origin="layout" path="M 2.08333E-7 1.48148E-6 L 2.08333E-7 0.03542 " pathEditMode="relative" rAng="0" ptsTypes="AA">
-                                      <p:cBhvr>
-                                        <p:cTn id="14" dur="700" spd="-100000" fill="hold"/>
-                                        <p:tgtEl>
-                                          <p:spTgt spid="18"/>
-                                        </p:tgtEl>
-                                        <p:attrNameLst>
-                                          <p:attrName>ppt_x</p:attrName>
-                                          <p:attrName>ppt_y</p:attrName>
-                                        </p:attrNameLst>
-                                      </p:cBhvr>
-                                      <p:rCtr x="0" y="1759"/>
-                                    </p:animMotion>
-                                  </p:childTnLst>
-                                </p:cTn>
-                              </p:par>
-                              <p:par>
-                                <p:cTn id="15" presetID="10" presetClass="entr" presetSubtype="0" fill="hold" grpId="0" nodeType="withEffect">
-                                  <p:stCondLst>
-                                    <p:cond delay="100"/>
-                                  </p:stCondLst>
-                                  <p:childTnLst>
-                                    <p:set>
-                                      <p:cBhvr>
-                                        <p:cTn id="16" dur="1" fill="hold">
-                                          <p:stCondLst>
-                                            <p:cond delay="0"/>
-                                          </p:stCondLst>
-                                        </p:cTn>
-                                        <p:tgtEl>
-                                          <p:spTgt spid="19"/>
-                                        </p:tgtEl>
-                                        <p:attrNameLst>
-                                          <p:attrName>style.visibility</p:attrName>
-                                        </p:attrNameLst>
-                                      </p:cBhvr>
-                                      <p:to>
-                                        <p:strVal val="visible"/>
-                                      </p:to>
-                                    </p:set>
-                                    <p:animEffect transition="in" filter="fade">
-                                      <p:cBhvr>
-                                        <p:cTn id="17" dur="500"/>
-                                        <p:tgtEl>
-                                          <p:spTgt spid="19"/>
-                                        </p:tgtEl>
-                                      </p:cBhvr>
-                                    </p:animEffect>
-                                  </p:childTnLst>
-                                </p:cTn>
-                              </p:par>
-                              <p:par>
-                                <p:cTn id="18" presetID="42" presetClass="path" presetSubtype="0" decel="100000" fill="hold" grpId="1" nodeType="withEffect">
-                                  <p:stCondLst>
-                                    <p:cond delay="100"/>
-                                  </p:stCondLst>
-                                  <p:childTnLst>
-                                    <p:animMotion origin="layout" path="M 2.08333E-7 1.48148E-6 L 2.08333E-7 0.03542 " pathEditMode="relative" rAng="0" ptsTypes="AA">
-                                      <p:cBhvr>
-                                        <p:cTn id="19" dur="700" spd="-100000" fill="hold"/>
-                                        <p:tgtEl>
-                                          <p:spTgt spid="19"/>
-                                        </p:tgtEl>
-                                        <p:attrNameLst>
-                                          <p:attrName>ppt_x</p:attrName>
-                                          <p:attrName>ppt_y</p:attrName>
-                                        </p:attrNameLst>
-                                      </p:cBhvr>
-                                      <p:rCtr x="0" y="1759"/>
-                                    </p:animMotion>
-                                  </p:childTnLst>
-                                </p:cTn>
-                              </p:par>
-                              <p:par>
-                                <p:cTn id="20" presetID="10" presetClass="entr" presetSubtype="0" fill="hold" grpId="0" nodeType="withEffect">
-                                  <p:stCondLst>
-                                    <p:cond delay="100"/>
-                                  </p:stCondLst>
-                                  <p:childTnLst>
-                                    <p:set>
-                                      <p:cBhvr>
-                                        <p:cTn id="21" dur="1" fill="hold">
-                                          <p:stCondLst>
-                                            <p:cond delay="0"/>
-                                          </p:stCondLst>
-                                        </p:cTn>
-                                        <p:tgtEl>
-                                          <p:spTgt spid="7"/>
-                                        </p:tgtEl>
-                                        <p:attrNameLst>
-                                          <p:attrName>style.visibility</p:attrName>
-                                        </p:attrNameLst>
-                                      </p:cBhvr>
-                                      <p:to>
-                                        <p:strVal val="visible"/>
-                                      </p:to>
-                                    </p:set>
-                                    <p:animEffect transition="in" filter="fade">
-                                      <p:cBhvr>
-                                        <p:cTn id="22" dur="500"/>
-                                        <p:tgtEl>
-                                          <p:spTgt spid="7"/>
-                                        </p:tgtEl>
-                                      </p:cBhvr>
-                                    </p:animEffect>
-                                  </p:childTnLst>
-                                </p:cTn>
-                              </p:par>
-                              <p:par>
-                                <p:cTn id="23" presetID="42" presetClass="path" presetSubtype="0" decel="100000" fill="hold" grpId="1" nodeType="withEffect">
-                                  <p:stCondLst>
-                                    <p:cond delay="100"/>
-                                  </p:stCondLst>
-                                  <p:childTnLst>
-                                    <p:animMotion origin="layout" path="M 2.08333E-7 1.48148E-6 L 2.08333E-7 0.03542 " pathEditMode="relative" rAng="0" ptsTypes="AA">
-                                      <p:cBhvr>
-                                        <p:cTn id="24" dur="700" spd="-100000" fill="hold"/>
-                                        <p:tgtEl>
-                                          <p:spTgt spid="7"/>
-                                        </p:tgtEl>
-                                        <p:attrNameLst>
-                                          <p:attrName>ppt_x</p:attrName>
-                                          <p:attrName>ppt_y</p:attrName>
-                                        </p:attrNameLst>
-                                      </p:cBhvr>
-                                      <p:rCtr x="0" y="1759"/>
-                                    </p:animMotion>
-                                  </p:childTnLst>
-                                </p:cTn>
-                              </p:par>
-                              <p:par>
-                                <p:cTn id="25" presetID="10" presetClass="entr" presetSubtype="0" fill="hold" grpId="0" nodeType="withEffect">
-                                  <p:stCondLst>
-                                    <p:cond delay="100"/>
-                                  </p:stCondLst>
-                                  <p:childTnLst>
-                                    <p:set>
-                                      <p:cBhvr>
-                                        <p:cTn id="26" dur="1" fill="hold">
-                                          <p:stCondLst>
-                                            <p:cond delay="0"/>
-                                          </p:stCondLst>
-                                        </p:cTn>
-                                        <p:tgtEl>
-                                          <p:spTgt spid="8"/>
-                                        </p:tgtEl>
-                                        <p:attrNameLst>
-                                          <p:attrName>style.visibility</p:attrName>
-                                        </p:attrNameLst>
-                                      </p:cBhvr>
-                                      <p:to>
-                                        <p:strVal val="visible"/>
-                                      </p:to>
-                                    </p:set>
-                                    <p:animEffect transition="in" filter="fade">
-                                      <p:cBhvr>
-                                        <p:cTn id="27" dur="500"/>
-                                        <p:tgtEl>
-                                          <p:spTgt spid="8"/>
-                                        </p:tgtEl>
-                                      </p:cBhvr>
-                                    </p:animEffect>
-                                  </p:childTnLst>
-                                </p:cTn>
-                              </p:par>
-                              <p:par>
-                                <p:cTn id="28" presetID="42" presetClass="path" presetSubtype="0" decel="100000" fill="hold" grpId="1" nodeType="withEffect">
-                                  <p:stCondLst>
-                                    <p:cond delay="100"/>
-                                  </p:stCondLst>
-                                  <p:childTnLst>
-                                    <p:animMotion origin="layout" path="M 2.08333E-7 1.48148E-6 L 2.08333E-7 0.03542 " pathEditMode="relative" rAng="0" ptsTypes="AA">
-                                      <p:cBhvr>
-                                        <p:cTn id="29" dur="700" spd="-100000" fill="hold"/>
-                                        <p:tgtEl>
-                                          <p:spTgt spid="8"/>
-                                        </p:tgtEl>
-                                        <p:attrNameLst>
-                                          <p:attrName>ppt_x</p:attrName>
-                                          <p:attrName>ppt_y</p:attrName>
-                                        </p:attrNameLst>
-                                      </p:cBhvr>
-                                      <p:rCtr x="0" y="1759"/>
-                                    </p:animMotion>
-                                  </p:childTnLst>
-                                </p:cTn>
-                              </p:par>
-                              <p:par>
-                                <p:cTn id="30" presetID="10" presetClass="entr" presetSubtype="0" fill="hold" grpId="0" nodeType="withEffect">
-                                  <p:stCondLst>
-                                    <p:cond delay="100"/>
-                                  </p:stCondLst>
-                                  <p:childTnLst>
-                                    <p:set>
-                                      <p:cBhvr>
-                                        <p:cTn id="31" dur="1" fill="hold">
-                                          <p:stCondLst>
-                                            <p:cond delay="0"/>
-                                          </p:stCondLst>
-                                        </p:cTn>
-                                        <p:tgtEl>
-                                          <p:spTgt spid="9"/>
-                                        </p:tgtEl>
-                                        <p:attrNameLst>
-                                          <p:attrName>style.visibility</p:attrName>
-                                        </p:attrNameLst>
-                                      </p:cBhvr>
-                                      <p:to>
-                                        <p:strVal val="visible"/>
-                                      </p:to>
-                                    </p:set>
-                                    <p:animEffect transition="in" filter="fade">
-                                      <p:cBhvr>
-                                        <p:cTn id="32" dur="500"/>
-                                        <p:tgtEl>
-                                          <p:spTgt spid="9"/>
-                                        </p:tgtEl>
-                                      </p:cBhvr>
-                                    </p:animEffect>
-                                  </p:childTnLst>
-                                </p:cTn>
-                              </p:par>
-                              <p:par>
-                                <p:cTn id="33" presetID="42" presetClass="path" presetSubtype="0" decel="100000" fill="hold" grpId="1" nodeType="withEffect">
-                                  <p:stCondLst>
-                                    <p:cond delay="100"/>
-                                  </p:stCondLst>
-                                  <p:childTnLst>
-                                    <p:animMotion origin="layout" path="M 2.08333E-7 1.48148E-6 L 2.08333E-7 0.03542 " pathEditMode="relative" rAng="0" ptsTypes="AA">
-                                      <p:cBhvr>
-                                        <p:cTn id="34" dur="700" spd="-100000" fill="hold"/>
-                                        <p:tgtEl>
-                                          <p:spTgt spid="9"/>
-                                        </p:tgtEl>
-                                        <p:attrNameLst>
-                                          <p:attrName>ppt_x</p:attrName>
-                                          <p:attrName>ppt_y</p:attrName>
-                                        </p:attrNameLst>
-                                      </p:cBhvr>
-                                      <p:rCtr x="0" y="1759"/>
-                                    </p:animMotion>
-                                  </p:childTnLst>
-                                </p:cTn>
-                              </p:par>
-                              <p:par>
-                                <p:cTn id="35" presetID="10" presetClass="entr" presetSubtype="0" fill="hold" grpId="0" nodeType="withEffect">
-                                  <p:stCondLst>
-                                    <p:cond delay="100"/>
-                                  </p:stCondLst>
-                                  <p:childTnLst>
-                                    <p:set>
-                                      <p:cBhvr>
-                                        <p:cTn id="36" dur="1" fill="hold">
-                                          <p:stCondLst>
-                                            <p:cond delay="0"/>
-                                          </p:stCondLst>
-                                        </p:cTn>
-                                        <p:tgtEl>
-                                          <p:spTgt spid="38"/>
-                                        </p:tgtEl>
-                                        <p:attrNameLst>
-                                          <p:attrName>style.visibility</p:attrName>
-                                        </p:attrNameLst>
-                                      </p:cBhvr>
-                                      <p:to>
-                                        <p:strVal val="visible"/>
-                                      </p:to>
-                                    </p:set>
-                                    <p:animEffect transition="in" filter="fade">
-                                      <p:cBhvr>
-                                        <p:cTn id="37" dur="500"/>
-                                        <p:tgtEl>
-                                          <p:spTgt spid="38"/>
-                                        </p:tgtEl>
-                                      </p:cBhvr>
-                                    </p:animEffect>
-                                  </p:childTnLst>
-                                </p:cTn>
-                              </p:par>
-                              <p:par>
-                                <p:cTn id="38" presetID="42" presetClass="path" presetSubtype="0" decel="100000" fill="hold" grpId="1" nodeType="withEffect">
-                                  <p:stCondLst>
-                                    <p:cond delay="100"/>
-                                  </p:stCondLst>
-                                  <p:childTnLst>
-                                    <p:animMotion origin="layout" path="M 2.08333E-7 1.48148E-6 L 2.08333E-7 0.03542 " pathEditMode="relative" rAng="0" ptsTypes="AA">
-                                      <p:cBhvr>
-                                        <p:cTn id="39" dur="700" spd="-100000" fill="hold"/>
-                                        <p:tgtEl>
-                                          <p:spTgt spid="38"/>
-                                        </p:tgtEl>
-                                        <p:attrNameLst>
-                                          <p:attrName>ppt_x</p:attrName>
-                                          <p:attrName>ppt_y</p:attrName>
-                                        </p:attrNameLst>
-                                      </p:cBhvr>
-                                      <p:rCtr x="0" y="1759"/>
-                                    </p:animMotion>
-                                  </p:childTnLst>
-                                </p:cTn>
-                              </p:par>
-                              <p:par>
-                                <p:cTn id="40" presetID="10" presetClass="entr" presetSubtype="0" fill="hold" grpId="0" nodeType="withEffect">
-                                  <p:stCondLst>
-                                    <p:cond delay="100"/>
-                                  </p:stCondLst>
-                                  <p:childTnLst>
-                                    <p:set>
-                                      <p:cBhvr>
-                                        <p:cTn id="41" dur="1" fill="hold">
-                                          <p:stCondLst>
-                                            <p:cond delay="0"/>
-                                          </p:stCondLst>
-                                        </p:cTn>
-                                        <p:tgtEl>
-                                          <p:spTgt spid="42"/>
-                                        </p:tgtEl>
-                                        <p:attrNameLst>
-                                          <p:attrName>style.visibility</p:attrName>
-                                        </p:attrNameLst>
-                                      </p:cBhvr>
-                                      <p:to>
-                                        <p:strVal val="visible"/>
-                                      </p:to>
-                                    </p:set>
-                                    <p:animEffect transition="in" filter="fade">
-                                      <p:cBhvr>
-                                        <p:cTn id="42" dur="500"/>
-                                        <p:tgtEl>
-                                          <p:spTgt spid="42"/>
-                                        </p:tgtEl>
-                                      </p:cBhvr>
-                                    </p:animEffect>
-                                  </p:childTnLst>
-                                </p:cTn>
-                              </p:par>
-                              <p:par>
-                                <p:cTn id="43" presetID="42" presetClass="path" presetSubtype="0" decel="100000" fill="hold" grpId="1" nodeType="withEffect">
-                                  <p:stCondLst>
-                                    <p:cond delay="100"/>
-                                  </p:stCondLst>
-                                  <p:childTnLst>
-                                    <p:animMotion origin="layout" path="M 2.08333E-7 1.48148E-6 L 2.08333E-7 0.03542 " pathEditMode="relative" rAng="0" ptsTypes="AA">
-                                      <p:cBhvr>
-                                        <p:cTn id="44" dur="700" spd="-100000" fill="hold"/>
-                                        <p:tgtEl>
-                                          <p:spTgt spid="42"/>
-                                        </p:tgtEl>
-                                        <p:attrNameLst>
-                                          <p:attrName>ppt_x</p:attrName>
-                                          <p:attrName>ppt_y</p:attrName>
-                                        </p:attrNameLst>
-                                      </p:cBhvr>
-                                      <p:rCtr x="0" y="1759"/>
-                                    </p:animMotion>
-                                  </p:childTnLst>
-                                </p:cTn>
-                              </p:par>
-                              <p:par>
-                                <p:cTn id="45" presetID="10" presetClass="entr" presetSubtype="0" fill="hold" grpId="0" nodeType="withEffect">
-                                  <p:stCondLst>
-                                    <p:cond delay="100"/>
-                                  </p:stCondLst>
-                                  <p:childTnLst>
-                                    <p:set>
-                                      <p:cBhvr>
-                                        <p:cTn id="46" dur="1" fill="hold">
-                                          <p:stCondLst>
-                                            <p:cond delay="0"/>
-                                          </p:stCondLst>
-                                        </p:cTn>
-                                        <p:tgtEl>
-                                          <p:spTgt spid="5"/>
-                                        </p:tgtEl>
-                                        <p:attrNameLst>
-                                          <p:attrName>style.visibility</p:attrName>
-                                        </p:attrNameLst>
-                                      </p:cBhvr>
-                                      <p:to>
-                                        <p:strVal val="visible"/>
-                                      </p:to>
-                                    </p:set>
-                                    <p:animEffect transition="in" filter="fade">
-                                      <p:cBhvr>
-                                        <p:cTn id="47" dur="500"/>
-                                        <p:tgtEl>
-                                          <p:spTgt spid="5"/>
-                                        </p:tgtEl>
-                                      </p:cBhvr>
-                                    </p:animEffect>
-                                  </p:childTnLst>
-                                </p:cTn>
-                              </p:par>
-                              <p:par>
-                                <p:cTn id="48" presetID="42" presetClass="path" presetSubtype="0" decel="100000" fill="hold" grpId="1" nodeType="withEffect">
-                                  <p:stCondLst>
-                                    <p:cond delay="100"/>
-                                  </p:stCondLst>
-                                  <p:childTnLst>
-                                    <p:animMotion origin="layout" path="M 2.08333E-7 1.48148E-6 L 2.08333E-7 0.03542 " pathEditMode="relative" rAng="0" ptsTypes="AA">
-                                      <p:cBhvr>
-                                        <p:cTn id="49" dur="700" spd="-100000" fill="hold"/>
-                                        <p:tgtEl>
-                                          <p:spTgt spid="5"/>
-                                        </p:tgtEl>
-                                        <p:attrNameLst>
-                                          <p:attrName>ppt_x</p:attrName>
-                                          <p:attrName>ppt_y</p:attrName>
-                                        </p:attrNameLst>
-                                      </p:cBhvr>
-                                      <p:rCtr x="0" y="1759"/>
-                                    </p:animMotion>
-                                  </p:childTnLst>
-                                </p:cTn>
-                              </p:par>
-                              <p:par>
-                                <p:cTn id="50" presetID="10" presetClass="entr" presetSubtype="0" fill="hold" grpId="0" nodeType="withEffect">
-                                  <p:stCondLst>
-                                    <p:cond delay="100"/>
-                                  </p:stCondLst>
-                                  <p:childTnLst>
-                                    <p:set>
-                                      <p:cBhvr>
-                                        <p:cTn id="51" dur="1" fill="hold">
-                                          <p:stCondLst>
-                                            <p:cond delay="0"/>
-                                          </p:stCondLst>
-                                        </p:cTn>
-                                        <p:tgtEl>
-                                          <p:spTgt spid="6"/>
-                                        </p:tgtEl>
-                                        <p:attrNameLst>
-                                          <p:attrName>style.visibility</p:attrName>
-                                        </p:attrNameLst>
-                                      </p:cBhvr>
-                                      <p:to>
-                                        <p:strVal val="visible"/>
-                                      </p:to>
-                                    </p:set>
-                                    <p:animEffect transition="in" filter="fade">
-                                      <p:cBhvr>
-                                        <p:cTn id="52" dur="500"/>
-                                        <p:tgtEl>
-                                          <p:spTgt spid="6"/>
-                                        </p:tgtEl>
-                                      </p:cBhvr>
-                                    </p:animEffect>
-                                  </p:childTnLst>
-                                </p:cTn>
-                              </p:par>
-                              <p:par>
-                                <p:cTn id="53" presetID="42" presetClass="path" presetSubtype="0" decel="100000" fill="hold" grpId="1" nodeType="withEffect">
-                                  <p:stCondLst>
-                                    <p:cond delay="100"/>
-                                  </p:stCondLst>
-                                  <p:childTnLst>
-                                    <p:animMotion origin="layout" path="M 2.08333E-7 1.48148E-6 L 2.08333E-7 0.03542 " pathEditMode="relative" rAng="0" ptsTypes="AA">
-                                      <p:cBhvr>
-                                        <p:cTn id="54" dur="700" spd="-100000" fill="hold"/>
-                                        <p:tgtEl>
-                                          <p:spTgt spid="6"/>
-                                        </p:tgtEl>
-                                        <p:attrNameLst>
-                                          <p:attrName>ppt_x</p:attrName>
-                                          <p:attrName>ppt_y</p:attrName>
-                                        </p:attrNameLst>
-                                      </p:cBhvr>
-                                      <p:rCtr x="0" y="1759"/>
-                                    </p:animMotion>
-                                  </p:childTnLst>
-                                </p:cTn>
-                              </p:par>
-                              <p:par>
-                                <p:cTn id="55" presetID="10" presetClass="entr" presetSubtype="0" fill="hold" grpId="0" nodeType="withEffect">
-                                  <p:stCondLst>
-                                    <p:cond delay="100"/>
-                                  </p:stCondLst>
-                                  <p:childTnLst>
-                                    <p:set>
-                                      <p:cBhvr>
-                                        <p:cTn id="56" dur="1" fill="hold">
-                                          <p:stCondLst>
-                                            <p:cond delay="0"/>
-                                          </p:stCondLst>
-                                        </p:cTn>
-                                        <p:tgtEl>
-                                          <p:spTgt spid="20"/>
-                                        </p:tgtEl>
-                                        <p:attrNameLst>
-                                          <p:attrName>style.visibility</p:attrName>
-                                        </p:attrNameLst>
-                                      </p:cBhvr>
-                                      <p:to>
-                                        <p:strVal val="visible"/>
-                                      </p:to>
-                                    </p:set>
-                                    <p:animEffect transition="in" filter="fade">
-                                      <p:cBhvr>
-                                        <p:cTn id="57" dur="500"/>
-                                        <p:tgtEl>
-                                          <p:spTgt spid="20"/>
-                                        </p:tgtEl>
-                                      </p:cBhvr>
-                                    </p:animEffect>
-                                  </p:childTnLst>
-                                </p:cTn>
-                              </p:par>
-                              <p:par>
-                                <p:cTn id="58" presetID="42" presetClass="path" presetSubtype="0" decel="100000" fill="hold" grpId="1" nodeType="withEffect">
-                                  <p:stCondLst>
-                                    <p:cond delay="100"/>
-                                  </p:stCondLst>
-                                  <p:childTnLst>
-                                    <p:animMotion origin="layout" path="M 2.08333E-7 1.48148E-6 L 2.08333E-7 0.03542 " pathEditMode="relative" rAng="0" ptsTypes="AA">
-                                      <p:cBhvr>
-                                        <p:cTn id="59" dur="700" spd="-100000" fill="hold"/>
-                                        <p:tgtEl>
-                                          <p:spTgt spid="20"/>
-                                        </p:tgtEl>
-                                        <p:attrNameLst>
-                                          <p:attrName>ppt_x</p:attrName>
-                                          <p:attrName>ppt_y</p:attrName>
-                                        </p:attrNameLst>
-                                      </p:cBhvr>
-                                      <p:rCtr x="0" y="1759"/>
-                                    </p:animMotion>
-                                  </p:childTnLst>
-                                </p:cTn>
-                              </p:par>
-                              <p:par>
-                                <p:cTn id="60" presetID="10" presetClass="entr" presetSubtype="0" fill="hold" grpId="0" nodeType="withEffect">
-                                  <p:stCondLst>
-                                    <p:cond delay="100"/>
-                                  </p:stCondLst>
-                                  <p:childTnLst>
-                                    <p:set>
-                                      <p:cBhvr>
-                                        <p:cTn id="61" dur="1" fill="hold">
-                                          <p:stCondLst>
-                                            <p:cond delay="0"/>
-                                          </p:stCondLst>
-                                        </p:cTn>
-                                        <p:tgtEl>
-                                          <p:spTgt spid="23"/>
-                                        </p:tgtEl>
-                                        <p:attrNameLst>
-                                          <p:attrName>style.visibility</p:attrName>
-                                        </p:attrNameLst>
-                                      </p:cBhvr>
-                                      <p:to>
-                                        <p:strVal val="visible"/>
-                                      </p:to>
-                                    </p:set>
-                                    <p:animEffect transition="in" filter="fade">
-                                      <p:cBhvr>
-                                        <p:cTn id="62" dur="500"/>
-                                        <p:tgtEl>
-                                          <p:spTgt spid="23"/>
-                                        </p:tgtEl>
-                                      </p:cBhvr>
-                                    </p:animEffect>
-                                  </p:childTnLst>
-                                </p:cTn>
-                              </p:par>
-                              <p:par>
-                                <p:cTn id="63" presetID="42" presetClass="path" presetSubtype="0" decel="100000" fill="hold" grpId="1" nodeType="withEffect">
-                                  <p:stCondLst>
-                                    <p:cond delay="100"/>
-                                  </p:stCondLst>
-                                  <p:childTnLst>
-                                    <p:animMotion origin="layout" path="M 2.08333E-7 1.48148E-6 L 2.08333E-7 0.03542 " pathEditMode="relative" rAng="0" ptsTypes="AA">
-                                      <p:cBhvr>
-                                        <p:cTn id="64" dur="700" spd="-100000" fill="hold"/>
-                                        <p:tgtEl>
-                                          <p:spTgt spid="23"/>
-                                        </p:tgtEl>
-                                        <p:attrNameLst>
-                                          <p:attrName>ppt_x</p:attrName>
-                                          <p:attrName>ppt_y</p:attrName>
-                                        </p:attrNameLst>
-                                      </p:cBhvr>
-                                      <p:rCtr x="0" y="1759"/>
-                                    </p:animMotion>
-                                  </p:childTnLst>
-                                </p:cTn>
-                              </p:par>
-                              <p:par>
-                                <p:cTn id="65" presetID="10" presetClass="entr" presetSubtype="0" fill="hold" nodeType="withEffect">
-                                  <p:stCondLst>
-                                    <p:cond delay="100"/>
-                                  </p:stCondLst>
-                                  <p:childTnLst>
-                                    <p:set>
-                                      <p:cBhvr>
-                                        <p:cTn id="66" dur="1" fill="hold">
-                                          <p:stCondLst>
-                                            <p:cond delay="0"/>
-                                          </p:stCondLst>
-                                        </p:cTn>
-                                        <p:tgtEl>
-                                          <p:spTgt spid="13"/>
-                                        </p:tgtEl>
-                                        <p:attrNameLst>
-                                          <p:attrName>style.visibility</p:attrName>
-                                        </p:attrNameLst>
-                                      </p:cBhvr>
-                                      <p:to>
-                                        <p:strVal val="visible"/>
-                                      </p:to>
-                                    </p:set>
-                                    <p:animEffect transition="in" filter="fade">
-                                      <p:cBhvr>
-                                        <p:cTn id="67" dur="500"/>
-                                        <p:tgtEl>
-                                          <p:spTgt spid="13"/>
-                                        </p:tgtEl>
-                                      </p:cBhvr>
-                                    </p:animEffect>
-                                  </p:childTnLst>
-                                </p:cTn>
-                              </p:par>
-                              <p:par>
-                                <p:cTn id="68" presetID="42" presetClass="path" presetSubtype="0" decel="100000" fill="hold" nodeType="withEffect">
-                                  <p:stCondLst>
-                                    <p:cond delay="100"/>
-                                  </p:stCondLst>
-                                  <p:childTnLst>
-                                    <p:animMotion origin="layout" path="M 2.08333E-7 1.48148E-6 L 2.08333E-7 0.03542 " pathEditMode="relative" rAng="0" ptsTypes="AA">
-                                      <p:cBhvr>
-                                        <p:cTn id="69" dur="700" spd="-100000" fill="hold"/>
-                                        <p:tgtEl>
-                                          <p:spTgt spid="13"/>
-                                        </p:tgtEl>
-                                        <p:attrNameLst>
-                                          <p:attrName>ppt_x</p:attrName>
-                                          <p:attrName>ppt_y</p:attrName>
-                                        </p:attrNameLst>
-                                      </p:cBhvr>
-                                      <p:rCtr x="0" y="1759"/>
-                                    </p:animMotion>
-                                  </p:childTnLst>
-                                </p:cTn>
-                              </p:par>
-                              <p:par>
-                                <p:cTn id="70" presetID="10" presetClass="entr" presetSubtype="0" fill="hold" nodeType="withEffect">
-                                  <p:stCondLst>
-                                    <p:cond delay="100"/>
-                                  </p:stCondLst>
-                                  <p:childTnLst>
-                                    <p:set>
-                                      <p:cBhvr>
-                                        <p:cTn id="71" dur="1" fill="hold">
-                                          <p:stCondLst>
-                                            <p:cond delay="0"/>
-                                          </p:stCondLst>
-                                        </p:cTn>
-                                        <p:tgtEl>
-                                          <p:spTgt spid="16"/>
-                                        </p:tgtEl>
-                                        <p:attrNameLst>
-                                          <p:attrName>style.visibility</p:attrName>
-                                        </p:attrNameLst>
-                                      </p:cBhvr>
-                                      <p:to>
-                                        <p:strVal val="visible"/>
-                                      </p:to>
-                                    </p:set>
-                                    <p:animEffect transition="in" filter="fade">
-                                      <p:cBhvr>
-                                        <p:cTn id="72" dur="500"/>
-                                        <p:tgtEl>
-                                          <p:spTgt spid="16"/>
-                                        </p:tgtEl>
-                                      </p:cBhvr>
-                                    </p:animEffect>
-                                  </p:childTnLst>
-                                </p:cTn>
-                              </p:par>
-                              <p:par>
-                                <p:cTn id="73" presetID="42" presetClass="path" presetSubtype="0" decel="100000" fill="hold" nodeType="withEffect">
-                                  <p:stCondLst>
-                                    <p:cond delay="100"/>
-                                  </p:stCondLst>
-                                  <p:childTnLst>
-                                    <p:animMotion origin="layout" path="M 2.08333E-7 1.48148E-6 L 2.08333E-7 0.03542 " pathEditMode="relative" rAng="0" ptsTypes="AA">
-                                      <p:cBhvr>
-                                        <p:cTn id="74" dur="700" spd="-100000" fill="hold"/>
-                                        <p:tgtEl>
-                                          <p:spTgt spid="16"/>
-                                        </p:tgtEl>
-                                        <p:attrNameLst>
-                                          <p:attrName>ppt_x</p:attrName>
-                                          <p:attrName>ppt_y</p:attrName>
-                                        </p:attrNameLst>
-                                      </p:cBhvr>
-                                      <p:rCtr x="0" y="1759"/>
-                                    </p:animMotion>
-                                  </p:childTnLst>
-                                </p:cTn>
-                              </p:par>
-                              <p:par>
-                                <p:cTn id="75" presetID="10" presetClass="entr" presetSubtype="0" fill="hold" nodeType="withEffect">
-                                  <p:stCondLst>
-                                    <p:cond delay="100"/>
-                                  </p:stCondLst>
-                                  <p:childTnLst>
-                                    <p:set>
-                                      <p:cBhvr>
-                                        <p:cTn id="76" dur="1" fill="hold">
-                                          <p:stCondLst>
-                                            <p:cond delay="0"/>
-                                          </p:stCondLst>
-                                        </p:cTn>
-                                        <p:tgtEl>
-                                          <p:spTgt spid="17"/>
-                                        </p:tgtEl>
-                                        <p:attrNameLst>
-                                          <p:attrName>style.visibility</p:attrName>
-                                        </p:attrNameLst>
-                                      </p:cBhvr>
-                                      <p:to>
-                                        <p:strVal val="visible"/>
-                                      </p:to>
-                                    </p:set>
-                                    <p:animEffect transition="in" filter="fade">
-                                      <p:cBhvr>
-                                        <p:cTn id="77" dur="500"/>
-                                        <p:tgtEl>
-                                          <p:spTgt spid="17"/>
-                                        </p:tgtEl>
-                                      </p:cBhvr>
-                                    </p:animEffect>
-                                  </p:childTnLst>
-                                </p:cTn>
-                              </p:par>
-                              <p:par>
-                                <p:cTn id="78" presetID="42" presetClass="path" presetSubtype="0" decel="100000" fill="hold" nodeType="withEffect">
-                                  <p:stCondLst>
-                                    <p:cond delay="100"/>
-                                  </p:stCondLst>
-                                  <p:childTnLst>
-                                    <p:animMotion origin="layout" path="M 2.08333E-7 1.48148E-6 L 2.08333E-7 0.03542 " pathEditMode="relative" rAng="0" ptsTypes="AA">
-                                      <p:cBhvr>
-                                        <p:cTn id="79" dur="700" spd="-100000" fill="hold"/>
-                                        <p:tgtEl>
-                                          <p:spTgt spid="17"/>
-                                        </p:tgtEl>
-                                        <p:attrNameLst>
-                                          <p:attrName>ppt_x</p:attrName>
-                                          <p:attrName>ppt_y</p:attrName>
-                                        </p:attrNameLst>
-                                      </p:cBhvr>
-                                      <p:rCtr x="0" y="1759"/>
-                                    </p:animMotion>
-                                  </p:childTnLst>
-                                </p:cTn>
-                              </p:par>
-                            </p:childTnLst>
-                          </p:cTn>
-                        </p:par>
-                      </p:childTnLst>
-                    </p:cTn>
-                  </p:par>
-                </p:childTnLst>
-              </p:cTn>
-              <p:prevCondLst>
-                <p:cond evt="onPrev" delay="0">
-                  <p:tgtEl>
-                    <p:sldTgt/>
-                  </p:tgtEl>
-                </p:cond>
-              </p:prevCondLst>
-              <p:nextCondLst>
-                <p:cond evt="onNext" delay="0">
-                  <p:tgtEl>
-                    <p:sldTgt/>
-                  </p:tgtEl>
-                </p:cond>
-              </p:nextCondLst>
-            </p:seq>
-          </p:childTnLst>
-        </p:cTn>
-      </p:par>
-    </p:tnLst>
-    <p:bldLst>
-      <p:bldP spid="18" grpId="0" animBg="1"/>
-      <p:bldP spid="18" grpId="1" animBg="1"/>
-      <p:bldP spid="2" grpId="0"/>
-      <p:bldP spid="2" grpId="1"/>
-      <p:bldP spid="19" grpId="0" animBg="1"/>
-      <p:bldP spid="19" grpId="1" animBg="1"/>
-      <p:bldP spid="7" grpId="0" animBg="1"/>
-      <p:bldP spid="7" grpId="1" animBg="1"/>
-      <p:bldP spid="8" grpId="0" animBg="1"/>
-      <p:bldP spid="8" grpId="1" animBg="1"/>
-      <p:bldP spid="9" grpId="0" animBg="1"/>
-      <p:bldP spid="9" grpId="1" animBg="1"/>
-      <p:bldP spid="38" grpId="0"/>
-      <p:bldP spid="38" grpId="1"/>
-      <p:bldP spid="42" grpId="0"/>
-      <p:bldP spid="42" grpId="1"/>
-      <p:bldP spid="5" grpId="0"/>
-      <p:bldP spid="5" grpId="1"/>
-      <p:bldP spid="6" grpId="0"/>
-      <p:bldP spid="6" grpId="1"/>
-      <p:bldP spid="20" grpId="0"/>
-      <p:bldP spid="20" grpId="1"/>
-      <p:bldP spid="23" grpId="0"/>
-      <p:bldP spid="23" grpId="1"/>
-    </p:bldLst>
-  </p:timing>
 </p:sld>
 </file>
 
@@ -15146,1506 +13831,6 @@
       </p:transition>
     </mc:Fallback>
   </mc:AlternateContent>
-  <p:timing>
-    <p:tnLst>
-      <p:par>
-        <p:cTn id="1" dur="indefinite" restart="never" nodeType="tmRoot">
-          <p:childTnLst>
-            <p:seq concurrent="1" nextAc="seek">
-              <p:cTn id="2" dur="indefinite" nodeType="mainSeq">
-                <p:childTnLst>
-                  <p:par>
-                    <p:cTn id="3" fill="hold">
-                      <p:stCondLst>
-                        <p:cond delay="indefinite"/>
-                        <p:cond evt="onBegin" delay="0">
-                          <p:tn val="2"/>
-                        </p:cond>
-                      </p:stCondLst>
-                      <p:childTnLst>
-                        <p:par>
-                          <p:cTn id="4" fill="hold">
-                            <p:stCondLst>
-                              <p:cond delay="0"/>
-                            </p:stCondLst>
-                            <p:childTnLst>
-                              <p:par>
-                                <p:cTn id="5" presetID="10" presetClass="entr" presetSubtype="0" fill="hold" grpId="0" nodeType="withEffect">
-                                  <p:stCondLst>
-                                    <p:cond delay="0"/>
-                                  </p:stCondLst>
-                                  <p:childTnLst>
-                                    <p:set>
-                                      <p:cBhvr>
-                                        <p:cTn id="6" dur="1" fill="hold">
-                                          <p:stCondLst>
-                                            <p:cond delay="0"/>
-                                          </p:stCondLst>
-                                        </p:cTn>
-                                        <p:tgtEl>
-                                          <p:spTgt spid="4"/>
-                                        </p:tgtEl>
-                                        <p:attrNameLst>
-                                          <p:attrName>style.visibility</p:attrName>
-                                        </p:attrNameLst>
-                                      </p:cBhvr>
-                                      <p:to>
-                                        <p:strVal val="visible"/>
-                                      </p:to>
-                                    </p:set>
-                                    <p:animEffect transition="in" filter="fade">
-                                      <p:cBhvr>
-                                        <p:cTn id="7" dur="500"/>
-                                        <p:tgtEl>
-                                          <p:spTgt spid="4"/>
-                                        </p:tgtEl>
-                                      </p:cBhvr>
-                                    </p:animEffect>
-                                  </p:childTnLst>
-                                </p:cTn>
-                              </p:par>
-                              <p:par>
-                                <p:cTn id="8" presetID="42" presetClass="path" presetSubtype="0" decel="100000" fill="hold" grpId="1" nodeType="withEffect">
-                                  <p:stCondLst>
-                                    <p:cond delay="0"/>
-                                  </p:stCondLst>
-                                  <p:childTnLst>
-                                    <p:animMotion origin="layout" path="M 0 -2.22222E-6 L 0 0.03542 " pathEditMode="relative" rAng="0" ptsTypes="AA">
-                                      <p:cBhvr>
-                                        <p:cTn id="9" dur="700" spd="-100000" fill="hold"/>
-                                        <p:tgtEl>
-                                          <p:spTgt spid="4"/>
-                                        </p:tgtEl>
-                                        <p:attrNameLst>
-                                          <p:attrName>ppt_x</p:attrName>
-                                          <p:attrName>ppt_y</p:attrName>
-                                        </p:attrNameLst>
-                                      </p:cBhvr>
-                                      <p:rCtr x="0" y="1759"/>
-                                    </p:animMotion>
-                                  </p:childTnLst>
-                                </p:cTn>
-                              </p:par>
-                              <p:par>
-                                <p:cTn id="10" presetID="10" presetClass="entr" presetSubtype="0" fill="hold" grpId="0" nodeType="withEffect">
-                                  <p:stCondLst>
-                                    <p:cond delay="100"/>
-                                  </p:stCondLst>
-                                  <p:childTnLst>
-                                    <p:set>
-                                      <p:cBhvr>
-                                        <p:cTn id="11" dur="1" fill="hold">
-                                          <p:stCondLst>
-                                            <p:cond delay="0"/>
-                                          </p:stCondLst>
-                                        </p:cTn>
-                                        <p:tgtEl>
-                                          <p:spTgt spid="7"/>
-                                        </p:tgtEl>
-                                        <p:attrNameLst>
-                                          <p:attrName>style.visibility</p:attrName>
-                                        </p:attrNameLst>
-                                      </p:cBhvr>
-                                      <p:to>
-                                        <p:strVal val="visible"/>
-                                      </p:to>
-                                    </p:set>
-                                    <p:animEffect transition="in" filter="fade">
-                                      <p:cBhvr>
-                                        <p:cTn id="12" dur="500"/>
-                                        <p:tgtEl>
-                                          <p:spTgt spid="7"/>
-                                        </p:tgtEl>
-                                      </p:cBhvr>
-                                    </p:animEffect>
-                                  </p:childTnLst>
-                                </p:cTn>
-                              </p:par>
-                              <p:par>
-                                <p:cTn id="13" presetID="42" presetClass="path" presetSubtype="0" decel="100000" fill="hold" grpId="1" nodeType="withEffect">
-                                  <p:stCondLst>
-                                    <p:cond delay="100"/>
-                                  </p:stCondLst>
-                                  <p:childTnLst>
-                                    <p:animMotion origin="layout" path="M 2.08333E-7 1.48148E-6 L 2.08333E-7 0.03542 " pathEditMode="relative" rAng="0" ptsTypes="AA">
-                                      <p:cBhvr>
-                                        <p:cTn id="14" dur="700" spd="-100000" fill="hold"/>
-                                        <p:tgtEl>
-                                          <p:spTgt spid="7"/>
-                                        </p:tgtEl>
-                                        <p:attrNameLst>
-                                          <p:attrName>ppt_x</p:attrName>
-                                          <p:attrName>ppt_y</p:attrName>
-                                        </p:attrNameLst>
-                                      </p:cBhvr>
-                                      <p:rCtr x="0" y="1759"/>
-                                    </p:animMotion>
-                                  </p:childTnLst>
-                                </p:cTn>
-                              </p:par>
-                              <p:par>
-                                <p:cTn id="15" presetID="10" presetClass="entr" presetSubtype="0" fill="hold" grpId="0" nodeType="withEffect">
-                                  <p:stCondLst>
-                                    <p:cond delay="100"/>
-                                  </p:stCondLst>
-                                  <p:childTnLst>
-                                    <p:set>
-                                      <p:cBhvr>
-                                        <p:cTn id="16" dur="1" fill="hold">
-                                          <p:stCondLst>
-                                            <p:cond delay="0"/>
-                                          </p:stCondLst>
-                                        </p:cTn>
-                                        <p:tgtEl>
-                                          <p:spTgt spid="38"/>
-                                        </p:tgtEl>
-                                        <p:attrNameLst>
-                                          <p:attrName>style.visibility</p:attrName>
-                                        </p:attrNameLst>
-                                      </p:cBhvr>
-                                      <p:to>
-                                        <p:strVal val="visible"/>
-                                      </p:to>
-                                    </p:set>
-                                    <p:animEffect transition="in" filter="fade">
-                                      <p:cBhvr>
-                                        <p:cTn id="17" dur="500"/>
-                                        <p:tgtEl>
-                                          <p:spTgt spid="38"/>
-                                        </p:tgtEl>
-                                      </p:cBhvr>
-                                    </p:animEffect>
-                                  </p:childTnLst>
-                                </p:cTn>
-                              </p:par>
-                              <p:par>
-                                <p:cTn id="18" presetID="42" presetClass="path" presetSubtype="0" decel="100000" fill="hold" grpId="1" nodeType="withEffect">
-                                  <p:stCondLst>
-                                    <p:cond delay="100"/>
-                                  </p:stCondLst>
-                                  <p:childTnLst>
-                                    <p:animMotion origin="layout" path="M 2.08333E-7 1.48148E-6 L 2.08333E-7 0.03542 " pathEditMode="relative" rAng="0" ptsTypes="AA">
-                                      <p:cBhvr>
-                                        <p:cTn id="19" dur="700" spd="-100000" fill="hold"/>
-                                        <p:tgtEl>
-                                          <p:spTgt spid="38"/>
-                                        </p:tgtEl>
-                                        <p:attrNameLst>
-                                          <p:attrName>ppt_x</p:attrName>
-                                          <p:attrName>ppt_y</p:attrName>
-                                        </p:attrNameLst>
-                                      </p:cBhvr>
-                                      <p:rCtr x="0" y="1759"/>
-                                    </p:animMotion>
-                                  </p:childTnLst>
-                                </p:cTn>
-                              </p:par>
-                              <p:par>
-                                <p:cTn id="20" presetID="10" presetClass="entr" presetSubtype="0" fill="hold" nodeType="withEffect">
-                                  <p:stCondLst>
-                                    <p:cond delay="100"/>
-                                  </p:stCondLst>
-                                  <p:childTnLst>
-                                    <p:set>
-                                      <p:cBhvr>
-                                        <p:cTn id="21" dur="1" fill="hold">
-                                          <p:stCondLst>
-                                            <p:cond delay="0"/>
-                                          </p:stCondLst>
-                                        </p:cTn>
-                                        <p:tgtEl>
-                                          <p:spTgt spid="198"/>
-                                        </p:tgtEl>
-                                        <p:attrNameLst>
-                                          <p:attrName>style.visibility</p:attrName>
-                                        </p:attrNameLst>
-                                      </p:cBhvr>
-                                      <p:to>
-                                        <p:strVal val="visible"/>
-                                      </p:to>
-                                    </p:set>
-                                    <p:animEffect transition="in" filter="fade">
-                                      <p:cBhvr>
-                                        <p:cTn id="22" dur="500"/>
-                                        <p:tgtEl>
-                                          <p:spTgt spid="198"/>
-                                        </p:tgtEl>
-                                      </p:cBhvr>
-                                    </p:animEffect>
-                                  </p:childTnLst>
-                                </p:cTn>
-                              </p:par>
-                              <p:par>
-                                <p:cTn id="23" presetID="42" presetClass="path" presetSubtype="0" decel="100000" fill="hold" nodeType="withEffect">
-                                  <p:stCondLst>
-                                    <p:cond delay="100"/>
-                                  </p:stCondLst>
-                                  <p:childTnLst>
-                                    <p:animMotion origin="layout" path="M 2.08333E-7 1.48148E-6 L 2.08333E-7 0.03542 " pathEditMode="relative" rAng="0" ptsTypes="AA">
-                                      <p:cBhvr>
-                                        <p:cTn id="24" dur="700" spd="-100000" fill="hold"/>
-                                        <p:tgtEl>
-                                          <p:spTgt spid="198"/>
-                                        </p:tgtEl>
-                                        <p:attrNameLst>
-                                          <p:attrName>ppt_x</p:attrName>
-                                          <p:attrName>ppt_y</p:attrName>
-                                        </p:attrNameLst>
-                                      </p:cBhvr>
-                                      <p:rCtr x="0" y="1759"/>
-                                    </p:animMotion>
-                                  </p:childTnLst>
-                                </p:cTn>
-                              </p:par>
-                              <p:par>
-                                <p:cTn id="25" presetID="10" presetClass="entr" presetSubtype="0" fill="hold" nodeType="withEffect">
-                                  <p:stCondLst>
-                                    <p:cond delay="100"/>
-                                  </p:stCondLst>
-                                  <p:childTnLst>
-                                    <p:set>
-                                      <p:cBhvr>
-                                        <p:cTn id="26" dur="1" fill="hold">
-                                          <p:stCondLst>
-                                            <p:cond delay="0"/>
-                                          </p:stCondLst>
-                                        </p:cTn>
-                                        <p:tgtEl>
-                                          <p:spTgt spid="154"/>
-                                        </p:tgtEl>
-                                        <p:attrNameLst>
-                                          <p:attrName>style.visibility</p:attrName>
-                                        </p:attrNameLst>
-                                      </p:cBhvr>
-                                      <p:to>
-                                        <p:strVal val="visible"/>
-                                      </p:to>
-                                    </p:set>
-                                    <p:animEffect transition="in" filter="fade">
-                                      <p:cBhvr>
-                                        <p:cTn id="27" dur="500"/>
-                                        <p:tgtEl>
-                                          <p:spTgt spid="154"/>
-                                        </p:tgtEl>
-                                      </p:cBhvr>
-                                    </p:animEffect>
-                                  </p:childTnLst>
-                                </p:cTn>
-                              </p:par>
-                              <p:par>
-                                <p:cTn id="28" presetID="42" presetClass="path" presetSubtype="0" decel="100000" fill="hold" nodeType="withEffect">
-                                  <p:stCondLst>
-                                    <p:cond delay="100"/>
-                                  </p:stCondLst>
-                                  <p:childTnLst>
-                                    <p:animMotion origin="layout" path="M 2.08333E-7 1.48148E-6 L 2.08333E-7 0.03542 " pathEditMode="relative" rAng="0" ptsTypes="AA">
-                                      <p:cBhvr>
-                                        <p:cTn id="29" dur="700" spd="-100000" fill="hold"/>
-                                        <p:tgtEl>
-                                          <p:spTgt spid="154"/>
-                                        </p:tgtEl>
-                                        <p:attrNameLst>
-                                          <p:attrName>ppt_x</p:attrName>
-                                          <p:attrName>ppt_y</p:attrName>
-                                        </p:attrNameLst>
-                                      </p:cBhvr>
-                                      <p:rCtr x="0" y="1759"/>
-                                    </p:animMotion>
-                                  </p:childTnLst>
-                                </p:cTn>
-                              </p:par>
-                              <p:par>
-                                <p:cTn id="30" presetID="10" presetClass="entr" presetSubtype="0" fill="hold" nodeType="withEffect">
-                                  <p:stCondLst>
-                                    <p:cond delay="100"/>
-                                  </p:stCondLst>
-                                  <p:childTnLst>
-                                    <p:set>
-                                      <p:cBhvr>
-                                        <p:cTn id="31" dur="1" fill="hold">
-                                          <p:stCondLst>
-                                            <p:cond delay="0"/>
-                                          </p:stCondLst>
-                                        </p:cTn>
-                                        <p:tgtEl>
-                                          <p:spTgt spid="155"/>
-                                        </p:tgtEl>
-                                        <p:attrNameLst>
-                                          <p:attrName>style.visibility</p:attrName>
-                                        </p:attrNameLst>
-                                      </p:cBhvr>
-                                      <p:to>
-                                        <p:strVal val="visible"/>
-                                      </p:to>
-                                    </p:set>
-                                    <p:animEffect transition="in" filter="fade">
-                                      <p:cBhvr>
-                                        <p:cTn id="32" dur="500"/>
-                                        <p:tgtEl>
-                                          <p:spTgt spid="155"/>
-                                        </p:tgtEl>
-                                      </p:cBhvr>
-                                    </p:animEffect>
-                                  </p:childTnLst>
-                                </p:cTn>
-                              </p:par>
-                              <p:par>
-                                <p:cTn id="33" presetID="42" presetClass="path" presetSubtype="0" decel="100000" fill="hold" nodeType="withEffect">
-                                  <p:stCondLst>
-                                    <p:cond delay="100"/>
-                                  </p:stCondLst>
-                                  <p:childTnLst>
-                                    <p:animMotion origin="layout" path="M 2.08333E-7 1.48148E-6 L 2.08333E-7 0.03542 " pathEditMode="relative" rAng="0" ptsTypes="AA">
-                                      <p:cBhvr>
-                                        <p:cTn id="34" dur="700" spd="-100000" fill="hold"/>
-                                        <p:tgtEl>
-                                          <p:spTgt spid="155"/>
-                                        </p:tgtEl>
-                                        <p:attrNameLst>
-                                          <p:attrName>ppt_x</p:attrName>
-                                          <p:attrName>ppt_y</p:attrName>
-                                        </p:attrNameLst>
-                                      </p:cBhvr>
-                                      <p:rCtr x="0" y="1759"/>
-                                    </p:animMotion>
-                                  </p:childTnLst>
-                                </p:cTn>
-                              </p:par>
-                              <p:par>
-                                <p:cTn id="35" presetID="10" presetClass="entr" presetSubtype="0" fill="hold" nodeType="withEffect">
-                                  <p:stCondLst>
-                                    <p:cond delay="100"/>
-                                  </p:stCondLst>
-                                  <p:childTnLst>
-                                    <p:set>
-                                      <p:cBhvr>
-                                        <p:cTn id="36" dur="1" fill="hold">
-                                          <p:stCondLst>
-                                            <p:cond delay="0"/>
-                                          </p:stCondLst>
-                                        </p:cTn>
-                                        <p:tgtEl>
-                                          <p:spTgt spid="156"/>
-                                        </p:tgtEl>
-                                        <p:attrNameLst>
-                                          <p:attrName>style.visibility</p:attrName>
-                                        </p:attrNameLst>
-                                      </p:cBhvr>
-                                      <p:to>
-                                        <p:strVal val="visible"/>
-                                      </p:to>
-                                    </p:set>
-                                    <p:animEffect transition="in" filter="fade">
-                                      <p:cBhvr>
-                                        <p:cTn id="37" dur="500"/>
-                                        <p:tgtEl>
-                                          <p:spTgt spid="156"/>
-                                        </p:tgtEl>
-                                      </p:cBhvr>
-                                    </p:animEffect>
-                                  </p:childTnLst>
-                                </p:cTn>
-                              </p:par>
-                              <p:par>
-                                <p:cTn id="38" presetID="42" presetClass="path" presetSubtype="0" decel="100000" fill="hold" nodeType="withEffect">
-                                  <p:stCondLst>
-                                    <p:cond delay="100"/>
-                                  </p:stCondLst>
-                                  <p:childTnLst>
-                                    <p:animMotion origin="layout" path="M 2.08333E-7 1.48148E-6 L 2.08333E-7 0.03542 " pathEditMode="relative" rAng="0" ptsTypes="AA">
-                                      <p:cBhvr>
-                                        <p:cTn id="39" dur="700" spd="-100000" fill="hold"/>
-                                        <p:tgtEl>
-                                          <p:spTgt spid="156"/>
-                                        </p:tgtEl>
-                                        <p:attrNameLst>
-                                          <p:attrName>ppt_x</p:attrName>
-                                          <p:attrName>ppt_y</p:attrName>
-                                        </p:attrNameLst>
-                                      </p:cBhvr>
-                                      <p:rCtr x="0" y="1759"/>
-                                    </p:animMotion>
-                                  </p:childTnLst>
-                                </p:cTn>
-                              </p:par>
-                              <p:par>
-                                <p:cTn id="40" presetID="10" presetClass="entr" presetSubtype="0" fill="hold" nodeType="withEffect">
-                                  <p:stCondLst>
-                                    <p:cond delay="100"/>
-                                  </p:stCondLst>
-                                  <p:childTnLst>
-                                    <p:set>
-                                      <p:cBhvr>
-                                        <p:cTn id="41" dur="1" fill="hold">
-                                          <p:stCondLst>
-                                            <p:cond delay="0"/>
-                                          </p:stCondLst>
-                                        </p:cTn>
-                                        <p:tgtEl>
-                                          <p:spTgt spid="157"/>
-                                        </p:tgtEl>
-                                        <p:attrNameLst>
-                                          <p:attrName>style.visibility</p:attrName>
-                                        </p:attrNameLst>
-                                      </p:cBhvr>
-                                      <p:to>
-                                        <p:strVal val="visible"/>
-                                      </p:to>
-                                    </p:set>
-                                    <p:animEffect transition="in" filter="fade">
-                                      <p:cBhvr>
-                                        <p:cTn id="42" dur="500"/>
-                                        <p:tgtEl>
-                                          <p:spTgt spid="157"/>
-                                        </p:tgtEl>
-                                      </p:cBhvr>
-                                    </p:animEffect>
-                                  </p:childTnLst>
-                                </p:cTn>
-                              </p:par>
-                              <p:par>
-                                <p:cTn id="43" presetID="42" presetClass="path" presetSubtype="0" decel="100000" fill="hold" nodeType="withEffect">
-                                  <p:stCondLst>
-                                    <p:cond delay="100"/>
-                                  </p:stCondLst>
-                                  <p:childTnLst>
-                                    <p:animMotion origin="layout" path="M 2.08333E-7 1.48148E-6 L 2.08333E-7 0.03542 " pathEditMode="relative" rAng="0" ptsTypes="AA">
-                                      <p:cBhvr>
-                                        <p:cTn id="44" dur="700" spd="-100000" fill="hold"/>
-                                        <p:tgtEl>
-                                          <p:spTgt spid="157"/>
-                                        </p:tgtEl>
-                                        <p:attrNameLst>
-                                          <p:attrName>ppt_x</p:attrName>
-                                          <p:attrName>ppt_y</p:attrName>
-                                        </p:attrNameLst>
-                                      </p:cBhvr>
-                                      <p:rCtr x="0" y="1759"/>
-                                    </p:animMotion>
-                                  </p:childTnLst>
-                                </p:cTn>
-                              </p:par>
-                              <p:par>
-                                <p:cTn id="45" presetID="10" presetClass="entr" presetSubtype="0" fill="hold" nodeType="withEffect">
-                                  <p:stCondLst>
-                                    <p:cond delay="100"/>
-                                  </p:stCondLst>
-                                  <p:childTnLst>
-                                    <p:set>
-                                      <p:cBhvr>
-                                        <p:cTn id="46" dur="1" fill="hold">
-                                          <p:stCondLst>
-                                            <p:cond delay="0"/>
-                                          </p:stCondLst>
-                                        </p:cTn>
-                                        <p:tgtEl>
-                                          <p:spTgt spid="159"/>
-                                        </p:tgtEl>
-                                        <p:attrNameLst>
-                                          <p:attrName>style.visibility</p:attrName>
-                                        </p:attrNameLst>
-                                      </p:cBhvr>
-                                      <p:to>
-                                        <p:strVal val="visible"/>
-                                      </p:to>
-                                    </p:set>
-                                    <p:animEffect transition="in" filter="fade">
-                                      <p:cBhvr>
-                                        <p:cTn id="47" dur="500"/>
-                                        <p:tgtEl>
-                                          <p:spTgt spid="159"/>
-                                        </p:tgtEl>
-                                      </p:cBhvr>
-                                    </p:animEffect>
-                                  </p:childTnLst>
-                                </p:cTn>
-                              </p:par>
-                              <p:par>
-                                <p:cTn id="48" presetID="42" presetClass="path" presetSubtype="0" decel="100000" fill="hold" nodeType="withEffect">
-                                  <p:stCondLst>
-                                    <p:cond delay="100"/>
-                                  </p:stCondLst>
-                                  <p:childTnLst>
-                                    <p:animMotion origin="layout" path="M 2.08333E-7 1.48148E-6 L 2.08333E-7 0.03542 " pathEditMode="relative" rAng="0" ptsTypes="AA">
-                                      <p:cBhvr>
-                                        <p:cTn id="49" dur="700" spd="-100000" fill="hold"/>
-                                        <p:tgtEl>
-                                          <p:spTgt spid="159"/>
-                                        </p:tgtEl>
-                                        <p:attrNameLst>
-                                          <p:attrName>ppt_x</p:attrName>
-                                          <p:attrName>ppt_y</p:attrName>
-                                        </p:attrNameLst>
-                                      </p:cBhvr>
-                                      <p:rCtr x="0" y="1759"/>
-                                    </p:animMotion>
-                                  </p:childTnLst>
-                                </p:cTn>
-                              </p:par>
-                              <p:par>
-                                <p:cTn id="50" presetID="10" presetClass="entr" presetSubtype="0" fill="hold" nodeType="withEffect">
-                                  <p:stCondLst>
-                                    <p:cond delay="100"/>
-                                  </p:stCondLst>
-                                  <p:childTnLst>
-                                    <p:set>
-                                      <p:cBhvr>
-                                        <p:cTn id="51" dur="1" fill="hold">
-                                          <p:stCondLst>
-                                            <p:cond delay="0"/>
-                                          </p:stCondLst>
-                                        </p:cTn>
-                                        <p:tgtEl>
-                                          <p:spTgt spid="160"/>
-                                        </p:tgtEl>
-                                        <p:attrNameLst>
-                                          <p:attrName>style.visibility</p:attrName>
-                                        </p:attrNameLst>
-                                      </p:cBhvr>
-                                      <p:to>
-                                        <p:strVal val="visible"/>
-                                      </p:to>
-                                    </p:set>
-                                    <p:animEffect transition="in" filter="fade">
-                                      <p:cBhvr>
-                                        <p:cTn id="52" dur="500"/>
-                                        <p:tgtEl>
-                                          <p:spTgt spid="160"/>
-                                        </p:tgtEl>
-                                      </p:cBhvr>
-                                    </p:animEffect>
-                                  </p:childTnLst>
-                                </p:cTn>
-                              </p:par>
-                              <p:par>
-                                <p:cTn id="53" presetID="42" presetClass="path" presetSubtype="0" decel="100000" fill="hold" nodeType="withEffect">
-                                  <p:stCondLst>
-                                    <p:cond delay="100"/>
-                                  </p:stCondLst>
-                                  <p:childTnLst>
-                                    <p:animMotion origin="layout" path="M 2.08333E-7 1.48148E-6 L 2.08333E-7 0.03542 " pathEditMode="relative" rAng="0" ptsTypes="AA">
-                                      <p:cBhvr>
-                                        <p:cTn id="54" dur="700" spd="-100000" fill="hold"/>
-                                        <p:tgtEl>
-                                          <p:spTgt spid="160"/>
-                                        </p:tgtEl>
-                                        <p:attrNameLst>
-                                          <p:attrName>ppt_x</p:attrName>
-                                          <p:attrName>ppt_y</p:attrName>
-                                        </p:attrNameLst>
-                                      </p:cBhvr>
-                                      <p:rCtr x="0" y="1759"/>
-                                    </p:animMotion>
-                                  </p:childTnLst>
-                                </p:cTn>
-                              </p:par>
-                              <p:par>
-                                <p:cTn id="55" presetID="10" presetClass="entr" presetSubtype="0" fill="hold" nodeType="withEffect">
-                                  <p:stCondLst>
-                                    <p:cond delay="100"/>
-                                  </p:stCondLst>
-                                  <p:childTnLst>
-                                    <p:set>
-                                      <p:cBhvr>
-                                        <p:cTn id="56" dur="1" fill="hold">
-                                          <p:stCondLst>
-                                            <p:cond delay="0"/>
-                                          </p:stCondLst>
-                                        </p:cTn>
-                                        <p:tgtEl>
-                                          <p:spTgt spid="161"/>
-                                        </p:tgtEl>
-                                        <p:attrNameLst>
-                                          <p:attrName>style.visibility</p:attrName>
-                                        </p:attrNameLst>
-                                      </p:cBhvr>
-                                      <p:to>
-                                        <p:strVal val="visible"/>
-                                      </p:to>
-                                    </p:set>
-                                    <p:animEffect transition="in" filter="fade">
-                                      <p:cBhvr>
-                                        <p:cTn id="57" dur="500"/>
-                                        <p:tgtEl>
-                                          <p:spTgt spid="161"/>
-                                        </p:tgtEl>
-                                      </p:cBhvr>
-                                    </p:animEffect>
-                                  </p:childTnLst>
-                                </p:cTn>
-                              </p:par>
-                              <p:par>
-                                <p:cTn id="58" presetID="42" presetClass="path" presetSubtype="0" decel="100000" fill="hold" nodeType="withEffect">
-                                  <p:stCondLst>
-                                    <p:cond delay="100"/>
-                                  </p:stCondLst>
-                                  <p:childTnLst>
-                                    <p:animMotion origin="layout" path="M 2.08333E-7 1.48148E-6 L 2.08333E-7 0.03542 " pathEditMode="relative" rAng="0" ptsTypes="AA">
-                                      <p:cBhvr>
-                                        <p:cTn id="59" dur="700" spd="-100000" fill="hold"/>
-                                        <p:tgtEl>
-                                          <p:spTgt spid="161"/>
-                                        </p:tgtEl>
-                                        <p:attrNameLst>
-                                          <p:attrName>ppt_x</p:attrName>
-                                          <p:attrName>ppt_y</p:attrName>
-                                        </p:attrNameLst>
-                                      </p:cBhvr>
-                                      <p:rCtr x="0" y="1759"/>
-                                    </p:animMotion>
-                                  </p:childTnLst>
-                                </p:cTn>
-                              </p:par>
-                              <p:par>
-                                <p:cTn id="60" presetID="10" presetClass="entr" presetSubtype="0" fill="hold" nodeType="withEffect">
-                                  <p:stCondLst>
-                                    <p:cond delay="100"/>
-                                  </p:stCondLst>
-                                  <p:childTnLst>
-                                    <p:set>
-                                      <p:cBhvr>
-                                        <p:cTn id="61" dur="1" fill="hold">
-                                          <p:stCondLst>
-                                            <p:cond delay="0"/>
-                                          </p:stCondLst>
-                                        </p:cTn>
-                                        <p:tgtEl>
-                                          <p:spTgt spid="167"/>
-                                        </p:tgtEl>
-                                        <p:attrNameLst>
-                                          <p:attrName>style.visibility</p:attrName>
-                                        </p:attrNameLst>
-                                      </p:cBhvr>
-                                      <p:to>
-                                        <p:strVal val="visible"/>
-                                      </p:to>
-                                    </p:set>
-                                    <p:animEffect transition="in" filter="fade">
-                                      <p:cBhvr>
-                                        <p:cTn id="62" dur="500"/>
-                                        <p:tgtEl>
-                                          <p:spTgt spid="167"/>
-                                        </p:tgtEl>
-                                      </p:cBhvr>
-                                    </p:animEffect>
-                                  </p:childTnLst>
-                                </p:cTn>
-                              </p:par>
-                              <p:par>
-                                <p:cTn id="63" presetID="42" presetClass="path" presetSubtype="0" decel="100000" fill="hold" nodeType="withEffect">
-                                  <p:stCondLst>
-                                    <p:cond delay="100"/>
-                                  </p:stCondLst>
-                                  <p:childTnLst>
-                                    <p:animMotion origin="layout" path="M 2.08333E-7 1.48148E-6 L 2.08333E-7 0.03542 " pathEditMode="relative" rAng="0" ptsTypes="AA">
-                                      <p:cBhvr>
-                                        <p:cTn id="64" dur="700" spd="-100000" fill="hold"/>
-                                        <p:tgtEl>
-                                          <p:spTgt spid="167"/>
-                                        </p:tgtEl>
-                                        <p:attrNameLst>
-                                          <p:attrName>ppt_x</p:attrName>
-                                          <p:attrName>ppt_y</p:attrName>
-                                        </p:attrNameLst>
-                                      </p:cBhvr>
-                                      <p:rCtr x="0" y="1759"/>
-                                    </p:animMotion>
-                                  </p:childTnLst>
-                                </p:cTn>
-                              </p:par>
-                              <p:par>
-                                <p:cTn id="65" presetID="10" presetClass="entr" presetSubtype="0" fill="hold" nodeType="withEffect">
-                                  <p:stCondLst>
-                                    <p:cond delay="100"/>
-                                  </p:stCondLst>
-                                  <p:childTnLst>
-                                    <p:set>
-                                      <p:cBhvr>
-                                        <p:cTn id="66" dur="1" fill="hold">
-                                          <p:stCondLst>
-                                            <p:cond delay="0"/>
-                                          </p:stCondLst>
-                                        </p:cTn>
-                                        <p:tgtEl>
-                                          <p:spTgt spid="168"/>
-                                        </p:tgtEl>
-                                        <p:attrNameLst>
-                                          <p:attrName>style.visibility</p:attrName>
-                                        </p:attrNameLst>
-                                      </p:cBhvr>
-                                      <p:to>
-                                        <p:strVal val="visible"/>
-                                      </p:to>
-                                    </p:set>
-                                    <p:animEffect transition="in" filter="fade">
-                                      <p:cBhvr>
-                                        <p:cTn id="67" dur="500"/>
-                                        <p:tgtEl>
-                                          <p:spTgt spid="168"/>
-                                        </p:tgtEl>
-                                      </p:cBhvr>
-                                    </p:animEffect>
-                                  </p:childTnLst>
-                                </p:cTn>
-                              </p:par>
-                              <p:par>
-                                <p:cTn id="68" presetID="42" presetClass="path" presetSubtype="0" decel="100000" fill="hold" nodeType="withEffect">
-                                  <p:stCondLst>
-                                    <p:cond delay="100"/>
-                                  </p:stCondLst>
-                                  <p:childTnLst>
-                                    <p:animMotion origin="layout" path="M 2.08333E-7 1.48148E-6 L 2.08333E-7 0.03542 " pathEditMode="relative" rAng="0" ptsTypes="AA">
-                                      <p:cBhvr>
-                                        <p:cTn id="69" dur="700" spd="-100000" fill="hold"/>
-                                        <p:tgtEl>
-                                          <p:spTgt spid="168"/>
-                                        </p:tgtEl>
-                                        <p:attrNameLst>
-                                          <p:attrName>ppt_x</p:attrName>
-                                          <p:attrName>ppt_y</p:attrName>
-                                        </p:attrNameLst>
-                                      </p:cBhvr>
-                                      <p:rCtr x="0" y="1759"/>
-                                    </p:animMotion>
-                                  </p:childTnLst>
-                                </p:cTn>
-                              </p:par>
-                              <p:par>
-                                <p:cTn id="70" presetID="10" presetClass="entr" presetSubtype="0" fill="hold" nodeType="withEffect">
-                                  <p:stCondLst>
-                                    <p:cond delay="100"/>
-                                  </p:stCondLst>
-                                  <p:childTnLst>
-                                    <p:set>
-                                      <p:cBhvr>
-                                        <p:cTn id="71" dur="1" fill="hold">
-                                          <p:stCondLst>
-                                            <p:cond delay="0"/>
-                                          </p:stCondLst>
-                                        </p:cTn>
-                                        <p:tgtEl>
-                                          <p:spTgt spid="169"/>
-                                        </p:tgtEl>
-                                        <p:attrNameLst>
-                                          <p:attrName>style.visibility</p:attrName>
-                                        </p:attrNameLst>
-                                      </p:cBhvr>
-                                      <p:to>
-                                        <p:strVal val="visible"/>
-                                      </p:to>
-                                    </p:set>
-                                    <p:animEffect transition="in" filter="fade">
-                                      <p:cBhvr>
-                                        <p:cTn id="72" dur="500"/>
-                                        <p:tgtEl>
-                                          <p:spTgt spid="169"/>
-                                        </p:tgtEl>
-                                      </p:cBhvr>
-                                    </p:animEffect>
-                                  </p:childTnLst>
-                                </p:cTn>
-                              </p:par>
-                              <p:par>
-                                <p:cTn id="73" presetID="42" presetClass="path" presetSubtype="0" decel="100000" fill="hold" nodeType="withEffect">
-                                  <p:stCondLst>
-                                    <p:cond delay="100"/>
-                                  </p:stCondLst>
-                                  <p:childTnLst>
-                                    <p:animMotion origin="layout" path="M 2.08333E-7 1.48148E-6 L 2.08333E-7 0.03542 " pathEditMode="relative" rAng="0" ptsTypes="AA">
-                                      <p:cBhvr>
-                                        <p:cTn id="74" dur="700" spd="-100000" fill="hold"/>
-                                        <p:tgtEl>
-                                          <p:spTgt spid="169"/>
-                                        </p:tgtEl>
-                                        <p:attrNameLst>
-                                          <p:attrName>ppt_x</p:attrName>
-                                          <p:attrName>ppt_y</p:attrName>
-                                        </p:attrNameLst>
-                                      </p:cBhvr>
-                                      <p:rCtr x="0" y="1759"/>
-                                    </p:animMotion>
-                                  </p:childTnLst>
-                                </p:cTn>
-                              </p:par>
-                              <p:par>
-                                <p:cTn id="75" presetID="10" presetClass="entr" presetSubtype="0" fill="hold" grpId="0" nodeType="withEffect">
-                                  <p:stCondLst>
-                                    <p:cond delay="100"/>
-                                  </p:stCondLst>
-                                  <p:childTnLst>
-                                    <p:set>
-                                      <p:cBhvr>
-                                        <p:cTn id="76" dur="1" fill="hold">
-                                          <p:stCondLst>
-                                            <p:cond delay="0"/>
-                                          </p:stCondLst>
-                                        </p:cTn>
-                                        <p:tgtEl>
-                                          <p:spTgt spid="39"/>
-                                        </p:tgtEl>
-                                        <p:attrNameLst>
-                                          <p:attrName>style.visibility</p:attrName>
-                                        </p:attrNameLst>
-                                      </p:cBhvr>
-                                      <p:to>
-                                        <p:strVal val="visible"/>
-                                      </p:to>
-                                    </p:set>
-                                    <p:animEffect transition="in" filter="fade">
-                                      <p:cBhvr>
-                                        <p:cTn id="77" dur="500"/>
-                                        <p:tgtEl>
-                                          <p:spTgt spid="39"/>
-                                        </p:tgtEl>
-                                      </p:cBhvr>
-                                    </p:animEffect>
-                                  </p:childTnLst>
-                                </p:cTn>
-                              </p:par>
-                              <p:par>
-                                <p:cTn id="78" presetID="42" presetClass="path" presetSubtype="0" decel="100000" fill="hold" grpId="1" nodeType="withEffect">
-                                  <p:stCondLst>
-                                    <p:cond delay="100"/>
-                                  </p:stCondLst>
-                                  <p:childTnLst>
-                                    <p:animMotion origin="layout" path="M 2.08333E-7 1.48148E-6 L 2.08333E-7 0.03542 " pathEditMode="relative" rAng="0" ptsTypes="AA">
-                                      <p:cBhvr>
-                                        <p:cTn id="79" dur="700" spd="-100000" fill="hold"/>
-                                        <p:tgtEl>
-                                          <p:spTgt spid="39"/>
-                                        </p:tgtEl>
-                                        <p:attrNameLst>
-                                          <p:attrName>ppt_x</p:attrName>
-                                          <p:attrName>ppt_y</p:attrName>
-                                        </p:attrNameLst>
-                                      </p:cBhvr>
-                                      <p:rCtr x="0" y="1759"/>
-                                    </p:animMotion>
-                                  </p:childTnLst>
-                                </p:cTn>
-                              </p:par>
-                              <p:par>
-                                <p:cTn id="80" presetID="10" presetClass="entr" presetSubtype="0" fill="hold" grpId="0" nodeType="withEffect">
-                                  <p:stCondLst>
-                                    <p:cond delay="100"/>
-                                  </p:stCondLst>
-                                  <p:childTnLst>
-                                    <p:set>
-                                      <p:cBhvr>
-                                        <p:cTn id="81" dur="1" fill="hold">
-                                          <p:stCondLst>
-                                            <p:cond delay="0"/>
-                                          </p:stCondLst>
-                                        </p:cTn>
-                                        <p:tgtEl>
-                                          <p:spTgt spid="40"/>
-                                        </p:tgtEl>
-                                        <p:attrNameLst>
-                                          <p:attrName>style.visibility</p:attrName>
-                                        </p:attrNameLst>
-                                      </p:cBhvr>
-                                      <p:to>
-                                        <p:strVal val="visible"/>
-                                      </p:to>
-                                    </p:set>
-                                    <p:animEffect transition="in" filter="fade">
-                                      <p:cBhvr>
-                                        <p:cTn id="82" dur="500"/>
-                                        <p:tgtEl>
-                                          <p:spTgt spid="40"/>
-                                        </p:tgtEl>
-                                      </p:cBhvr>
-                                    </p:animEffect>
-                                  </p:childTnLst>
-                                </p:cTn>
-                              </p:par>
-                              <p:par>
-                                <p:cTn id="83" presetID="42" presetClass="path" presetSubtype="0" decel="100000" fill="hold" grpId="1" nodeType="withEffect">
-                                  <p:stCondLst>
-                                    <p:cond delay="100"/>
-                                  </p:stCondLst>
-                                  <p:childTnLst>
-                                    <p:animMotion origin="layout" path="M 2.08333E-7 1.48148E-6 L 2.08333E-7 0.03542 " pathEditMode="relative" rAng="0" ptsTypes="AA">
-                                      <p:cBhvr>
-                                        <p:cTn id="84" dur="700" spd="-100000" fill="hold"/>
-                                        <p:tgtEl>
-                                          <p:spTgt spid="40"/>
-                                        </p:tgtEl>
-                                        <p:attrNameLst>
-                                          <p:attrName>ppt_x</p:attrName>
-                                          <p:attrName>ppt_y</p:attrName>
-                                        </p:attrNameLst>
-                                      </p:cBhvr>
-                                      <p:rCtr x="0" y="1759"/>
-                                    </p:animMotion>
-                                  </p:childTnLst>
-                                </p:cTn>
-                              </p:par>
-                              <p:par>
-                                <p:cTn id="85" presetID="10" presetClass="entr" presetSubtype="0" fill="hold" grpId="0" nodeType="withEffect">
-                                  <p:stCondLst>
-                                    <p:cond delay="100"/>
-                                  </p:stCondLst>
-                                  <p:childTnLst>
-                                    <p:set>
-                                      <p:cBhvr>
-                                        <p:cTn id="86" dur="1" fill="hold">
-                                          <p:stCondLst>
-                                            <p:cond delay="0"/>
-                                          </p:stCondLst>
-                                        </p:cTn>
-                                        <p:tgtEl>
-                                          <p:spTgt spid="10"/>
-                                        </p:tgtEl>
-                                        <p:attrNameLst>
-                                          <p:attrName>style.visibility</p:attrName>
-                                        </p:attrNameLst>
-                                      </p:cBhvr>
-                                      <p:to>
-                                        <p:strVal val="visible"/>
-                                      </p:to>
-                                    </p:set>
-                                    <p:animEffect transition="in" filter="fade">
-                                      <p:cBhvr>
-                                        <p:cTn id="87" dur="500"/>
-                                        <p:tgtEl>
-                                          <p:spTgt spid="10"/>
-                                        </p:tgtEl>
-                                      </p:cBhvr>
-                                    </p:animEffect>
-                                  </p:childTnLst>
-                                </p:cTn>
-                              </p:par>
-                              <p:par>
-                                <p:cTn id="88" presetID="42" presetClass="path" presetSubtype="0" decel="100000" fill="hold" grpId="1" nodeType="withEffect">
-                                  <p:stCondLst>
-                                    <p:cond delay="100"/>
-                                  </p:stCondLst>
-                                  <p:childTnLst>
-                                    <p:animMotion origin="layout" path="M 0 4.81481E-6 L 0 0.03541 " pathEditMode="relative" rAng="0" ptsTypes="AA">
-                                      <p:cBhvr>
-                                        <p:cTn id="89" dur="700" spd="-100000" fill="hold"/>
-                                        <p:tgtEl>
-                                          <p:spTgt spid="10"/>
-                                        </p:tgtEl>
-                                        <p:attrNameLst>
-                                          <p:attrName>ppt_x</p:attrName>
-                                          <p:attrName>ppt_y</p:attrName>
-                                        </p:attrNameLst>
-                                      </p:cBhvr>
-                                      <p:rCtr x="0" y="1759"/>
-                                    </p:animMotion>
-                                  </p:childTnLst>
-                                </p:cTn>
-                              </p:par>
-                              <p:par>
-                                <p:cTn id="90" presetID="10" presetClass="entr" presetSubtype="0" fill="hold" grpId="0" nodeType="withEffect">
-                                  <p:stCondLst>
-                                    <p:cond delay="100"/>
-                                  </p:stCondLst>
-                                  <p:childTnLst>
-                                    <p:set>
-                                      <p:cBhvr>
-                                        <p:cTn id="91" dur="1" fill="hold">
-                                          <p:stCondLst>
-                                            <p:cond delay="0"/>
-                                          </p:stCondLst>
-                                        </p:cTn>
-                                        <p:tgtEl>
-                                          <p:spTgt spid="12"/>
-                                        </p:tgtEl>
-                                        <p:attrNameLst>
-                                          <p:attrName>style.visibility</p:attrName>
-                                        </p:attrNameLst>
-                                      </p:cBhvr>
-                                      <p:to>
-                                        <p:strVal val="visible"/>
-                                      </p:to>
-                                    </p:set>
-                                    <p:animEffect transition="in" filter="fade">
-                                      <p:cBhvr>
-                                        <p:cTn id="92" dur="500"/>
-                                        <p:tgtEl>
-                                          <p:spTgt spid="12"/>
-                                        </p:tgtEl>
-                                      </p:cBhvr>
-                                    </p:animEffect>
-                                  </p:childTnLst>
-                                </p:cTn>
-                              </p:par>
-                              <p:par>
-                                <p:cTn id="93" presetID="42" presetClass="path" presetSubtype="0" decel="100000" fill="hold" grpId="1" nodeType="withEffect">
-                                  <p:stCondLst>
-                                    <p:cond delay="100"/>
-                                  </p:stCondLst>
-                                  <p:childTnLst>
-                                    <p:animMotion origin="layout" path="M 2.08333E-7 1.48148E-6 L 2.08333E-7 0.03542 " pathEditMode="relative" rAng="0" ptsTypes="AA">
-                                      <p:cBhvr>
-                                        <p:cTn id="94" dur="700" spd="-100000" fill="hold"/>
-                                        <p:tgtEl>
-                                          <p:spTgt spid="12"/>
-                                        </p:tgtEl>
-                                        <p:attrNameLst>
-                                          <p:attrName>ppt_x</p:attrName>
-                                          <p:attrName>ppt_y</p:attrName>
-                                        </p:attrNameLst>
-                                      </p:cBhvr>
-                                      <p:rCtr x="0" y="1759"/>
-                                    </p:animMotion>
-                                  </p:childTnLst>
-                                </p:cTn>
-                              </p:par>
-                              <p:par>
-                                <p:cTn id="95" presetID="10" presetClass="entr" presetSubtype="0" fill="hold" grpId="0" nodeType="withEffect">
-                                  <p:stCondLst>
-                                    <p:cond delay="100"/>
-                                  </p:stCondLst>
-                                  <p:childTnLst>
-                                    <p:set>
-                                      <p:cBhvr>
-                                        <p:cTn id="96" dur="1" fill="hold">
-                                          <p:stCondLst>
-                                            <p:cond delay="0"/>
-                                          </p:stCondLst>
-                                        </p:cTn>
-                                        <p:tgtEl>
-                                          <p:spTgt spid="15"/>
-                                        </p:tgtEl>
-                                        <p:attrNameLst>
-                                          <p:attrName>style.visibility</p:attrName>
-                                        </p:attrNameLst>
-                                      </p:cBhvr>
-                                      <p:to>
-                                        <p:strVal val="visible"/>
-                                      </p:to>
-                                    </p:set>
-                                    <p:animEffect transition="in" filter="fade">
-                                      <p:cBhvr>
-                                        <p:cTn id="97" dur="500"/>
-                                        <p:tgtEl>
-                                          <p:spTgt spid="15"/>
-                                        </p:tgtEl>
-                                      </p:cBhvr>
-                                    </p:animEffect>
-                                  </p:childTnLst>
-                                </p:cTn>
-                              </p:par>
-                              <p:par>
-                                <p:cTn id="98" presetID="42" presetClass="path" presetSubtype="0" decel="100000" fill="hold" grpId="1" nodeType="withEffect">
-                                  <p:stCondLst>
-                                    <p:cond delay="100"/>
-                                  </p:stCondLst>
-                                  <p:childTnLst>
-                                    <p:animMotion origin="layout" path="M 2.08333E-7 1.48148E-6 L 2.08333E-7 0.03542 " pathEditMode="relative" rAng="0" ptsTypes="AA">
-                                      <p:cBhvr>
-                                        <p:cTn id="99" dur="700" spd="-100000" fill="hold"/>
-                                        <p:tgtEl>
-                                          <p:spTgt spid="15"/>
-                                        </p:tgtEl>
-                                        <p:attrNameLst>
-                                          <p:attrName>ppt_x</p:attrName>
-                                          <p:attrName>ppt_y</p:attrName>
-                                        </p:attrNameLst>
-                                      </p:cBhvr>
-                                      <p:rCtr x="0" y="1759"/>
-                                    </p:animMotion>
-                                  </p:childTnLst>
-                                </p:cTn>
-                              </p:par>
-                              <p:par>
-                                <p:cTn id="100" presetID="10" presetClass="entr" presetSubtype="0" fill="hold" grpId="0" nodeType="withEffect">
-                                  <p:stCondLst>
-                                    <p:cond delay="100"/>
-                                  </p:stCondLst>
-                                  <p:childTnLst>
-                                    <p:set>
-                                      <p:cBhvr>
-                                        <p:cTn id="101" dur="1" fill="hold">
-                                          <p:stCondLst>
-                                            <p:cond delay="0"/>
-                                          </p:stCondLst>
-                                        </p:cTn>
-                                        <p:tgtEl>
-                                          <p:spTgt spid="18"/>
-                                        </p:tgtEl>
-                                        <p:attrNameLst>
-                                          <p:attrName>style.visibility</p:attrName>
-                                        </p:attrNameLst>
-                                      </p:cBhvr>
-                                      <p:to>
-                                        <p:strVal val="visible"/>
-                                      </p:to>
-                                    </p:set>
-                                    <p:animEffect transition="in" filter="fade">
-                                      <p:cBhvr>
-                                        <p:cTn id="102" dur="500"/>
-                                        <p:tgtEl>
-                                          <p:spTgt spid="18"/>
-                                        </p:tgtEl>
-                                      </p:cBhvr>
-                                    </p:animEffect>
-                                  </p:childTnLst>
-                                </p:cTn>
-                              </p:par>
-                              <p:par>
-                                <p:cTn id="103" presetID="42" presetClass="path" presetSubtype="0" decel="100000" fill="hold" grpId="1" nodeType="withEffect">
-                                  <p:stCondLst>
-                                    <p:cond delay="100"/>
-                                  </p:stCondLst>
-                                  <p:childTnLst>
-                                    <p:animMotion origin="layout" path="M 2.08333E-7 1.48148E-6 L 2.08333E-7 0.03542 " pathEditMode="relative" rAng="0" ptsTypes="AA">
-                                      <p:cBhvr>
-                                        <p:cTn id="104" dur="700" spd="-100000" fill="hold"/>
-                                        <p:tgtEl>
-                                          <p:spTgt spid="18"/>
-                                        </p:tgtEl>
-                                        <p:attrNameLst>
-                                          <p:attrName>ppt_x</p:attrName>
-                                          <p:attrName>ppt_y</p:attrName>
-                                        </p:attrNameLst>
-                                      </p:cBhvr>
-                                      <p:rCtr x="0" y="1759"/>
-                                    </p:animMotion>
-                                  </p:childTnLst>
-                                </p:cTn>
-                              </p:par>
-                              <p:par>
-                                <p:cTn id="105" presetID="10" presetClass="entr" presetSubtype="0" fill="hold" nodeType="withEffect">
-                                  <p:stCondLst>
-                                    <p:cond delay="100"/>
-                                  </p:stCondLst>
-                                  <p:childTnLst>
-                                    <p:set>
-                                      <p:cBhvr>
-                                        <p:cTn id="106" dur="1" fill="hold">
-                                          <p:stCondLst>
-                                            <p:cond delay="0"/>
-                                          </p:stCondLst>
-                                        </p:cTn>
-                                        <p:tgtEl>
-                                          <p:spTgt spid="197"/>
-                                        </p:tgtEl>
-                                        <p:attrNameLst>
-                                          <p:attrName>style.visibility</p:attrName>
-                                        </p:attrNameLst>
-                                      </p:cBhvr>
-                                      <p:to>
-                                        <p:strVal val="visible"/>
-                                      </p:to>
-                                    </p:set>
-                                    <p:animEffect transition="in" filter="fade">
-                                      <p:cBhvr>
-                                        <p:cTn id="107" dur="500"/>
-                                        <p:tgtEl>
-                                          <p:spTgt spid="197"/>
-                                        </p:tgtEl>
-                                      </p:cBhvr>
-                                    </p:animEffect>
-                                  </p:childTnLst>
-                                </p:cTn>
-                              </p:par>
-                              <p:par>
-                                <p:cTn id="108" presetID="42" presetClass="path" presetSubtype="0" decel="100000" fill="hold" nodeType="withEffect">
-                                  <p:stCondLst>
-                                    <p:cond delay="100"/>
-                                  </p:stCondLst>
-                                  <p:childTnLst>
-                                    <p:animMotion origin="layout" path="M 2.08333E-7 1.48148E-6 L 2.08333E-7 0.03542 " pathEditMode="relative" rAng="0" ptsTypes="AA">
-                                      <p:cBhvr>
-                                        <p:cTn id="109" dur="700" spd="-100000" fill="hold"/>
-                                        <p:tgtEl>
-                                          <p:spTgt spid="197"/>
-                                        </p:tgtEl>
-                                        <p:attrNameLst>
-                                          <p:attrName>ppt_x</p:attrName>
-                                          <p:attrName>ppt_y</p:attrName>
-                                        </p:attrNameLst>
-                                      </p:cBhvr>
-                                      <p:rCtr x="0" y="1759"/>
-                                    </p:animMotion>
-                                  </p:childTnLst>
-                                </p:cTn>
-                              </p:par>
-                              <p:par>
-                                <p:cTn id="110" presetID="10" presetClass="entr" presetSubtype="0" fill="hold" nodeType="withEffect">
-                                  <p:stCondLst>
-                                    <p:cond delay="100"/>
-                                  </p:stCondLst>
-                                  <p:childTnLst>
-                                    <p:set>
-                                      <p:cBhvr>
-                                        <p:cTn id="111" dur="1" fill="hold">
-                                          <p:stCondLst>
-                                            <p:cond delay="0"/>
-                                          </p:stCondLst>
-                                        </p:cTn>
-                                        <p:tgtEl>
-                                          <p:spTgt spid="202"/>
-                                        </p:tgtEl>
-                                        <p:attrNameLst>
-                                          <p:attrName>style.visibility</p:attrName>
-                                        </p:attrNameLst>
-                                      </p:cBhvr>
-                                      <p:to>
-                                        <p:strVal val="visible"/>
-                                      </p:to>
-                                    </p:set>
-                                    <p:animEffect transition="in" filter="fade">
-                                      <p:cBhvr>
-                                        <p:cTn id="112" dur="500"/>
-                                        <p:tgtEl>
-                                          <p:spTgt spid="202"/>
-                                        </p:tgtEl>
-                                      </p:cBhvr>
-                                    </p:animEffect>
-                                  </p:childTnLst>
-                                </p:cTn>
-                              </p:par>
-                              <p:par>
-                                <p:cTn id="113" presetID="42" presetClass="path" presetSubtype="0" decel="100000" fill="hold" nodeType="withEffect">
-                                  <p:stCondLst>
-                                    <p:cond delay="100"/>
-                                  </p:stCondLst>
-                                  <p:childTnLst>
-                                    <p:animMotion origin="layout" path="M 2.08333E-7 1.48148E-6 L 2.08333E-7 0.03542 " pathEditMode="relative" rAng="0" ptsTypes="AA">
-                                      <p:cBhvr>
-                                        <p:cTn id="114" dur="700" spd="-100000" fill="hold"/>
-                                        <p:tgtEl>
-                                          <p:spTgt spid="202"/>
-                                        </p:tgtEl>
-                                        <p:attrNameLst>
-                                          <p:attrName>ppt_x</p:attrName>
-                                          <p:attrName>ppt_y</p:attrName>
-                                        </p:attrNameLst>
-                                      </p:cBhvr>
-                                      <p:rCtr x="0" y="1759"/>
-                                    </p:animMotion>
-                                  </p:childTnLst>
-                                </p:cTn>
-                              </p:par>
-                              <p:par>
-                                <p:cTn id="115" presetID="10" presetClass="entr" presetSubtype="0" fill="hold" nodeType="withEffect">
-                                  <p:stCondLst>
-                                    <p:cond delay="100"/>
-                                  </p:stCondLst>
-                                  <p:childTnLst>
-                                    <p:set>
-                                      <p:cBhvr>
-                                        <p:cTn id="116" dur="1" fill="hold">
-                                          <p:stCondLst>
-                                            <p:cond delay="0"/>
-                                          </p:stCondLst>
-                                        </p:cTn>
-                                        <p:tgtEl>
-                                          <p:spTgt spid="51"/>
-                                        </p:tgtEl>
-                                        <p:attrNameLst>
-                                          <p:attrName>style.visibility</p:attrName>
-                                        </p:attrNameLst>
-                                      </p:cBhvr>
-                                      <p:to>
-                                        <p:strVal val="visible"/>
-                                      </p:to>
-                                    </p:set>
-                                    <p:animEffect transition="in" filter="fade">
-                                      <p:cBhvr>
-                                        <p:cTn id="117" dur="500"/>
-                                        <p:tgtEl>
-                                          <p:spTgt spid="51"/>
-                                        </p:tgtEl>
-                                      </p:cBhvr>
-                                    </p:animEffect>
-                                  </p:childTnLst>
-                                </p:cTn>
-                              </p:par>
-                              <p:par>
-                                <p:cTn id="118" presetID="42" presetClass="path" presetSubtype="0" decel="100000" fill="hold" nodeType="withEffect">
-                                  <p:stCondLst>
-                                    <p:cond delay="100"/>
-                                  </p:stCondLst>
-                                  <p:childTnLst>
-                                    <p:animMotion origin="layout" path="M 2.08333E-7 1.48148E-6 L 2.08333E-7 0.03542 " pathEditMode="relative" rAng="0" ptsTypes="AA">
-                                      <p:cBhvr>
-                                        <p:cTn id="119" dur="700" spd="-100000" fill="hold"/>
-                                        <p:tgtEl>
-                                          <p:spTgt spid="51"/>
-                                        </p:tgtEl>
-                                        <p:attrNameLst>
-                                          <p:attrName>ppt_x</p:attrName>
-                                          <p:attrName>ppt_y</p:attrName>
-                                        </p:attrNameLst>
-                                      </p:cBhvr>
-                                      <p:rCtr x="0" y="1759"/>
-                                    </p:animMotion>
-                                  </p:childTnLst>
-                                </p:cTn>
-                              </p:par>
-                              <p:par>
-                                <p:cTn id="120" presetID="10" presetClass="entr" presetSubtype="0" fill="hold" grpId="0" nodeType="withEffect">
-                                  <p:stCondLst>
-                                    <p:cond delay="100"/>
-                                  </p:stCondLst>
-                                  <p:childTnLst>
-                                    <p:set>
-                                      <p:cBhvr>
-                                        <p:cTn id="121" dur="1" fill="hold">
-                                          <p:stCondLst>
-                                            <p:cond delay="0"/>
-                                          </p:stCondLst>
-                                        </p:cTn>
-                                        <p:tgtEl>
-                                          <p:spTgt spid="203"/>
-                                        </p:tgtEl>
-                                        <p:attrNameLst>
-                                          <p:attrName>style.visibility</p:attrName>
-                                        </p:attrNameLst>
-                                      </p:cBhvr>
-                                      <p:to>
-                                        <p:strVal val="visible"/>
-                                      </p:to>
-                                    </p:set>
-                                    <p:animEffect transition="in" filter="fade">
-                                      <p:cBhvr>
-                                        <p:cTn id="122" dur="500"/>
-                                        <p:tgtEl>
-                                          <p:spTgt spid="203"/>
-                                        </p:tgtEl>
-                                      </p:cBhvr>
-                                    </p:animEffect>
-                                  </p:childTnLst>
-                                </p:cTn>
-                              </p:par>
-                              <p:par>
-                                <p:cTn id="123" presetID="42" presetClass="path" presetSubtype="0" decel="100000" fill="hold" grpId="1" nodeType="withEffect">
-                                  <p:stCondLst>
-                                    <p:cond delay="100"/>
-                                  </p:stCondLst>
-                                  <p:childTnLst>
-                                    <p:animMotion origin="layout" path="M 2.08333E-7 1.48148E-6 L 2.08333E-7 0.03542 " pathEditMode="relative" rAng="0" ptsTypes="AA">
-                                      <p:cBhvr>
-                                        <p:cTn id="124" dur="700" spd="-100000" fill="hold"/>
-                                        <p:tgtEl>
-                                          <p:spTgt spid="203"/>
-                                        </p:tgtEl>
-                                        <p:attrNameLst>
-                                          <p:attrName>ppt_x</p:attrName>
-                                          <p:attrName>ppt_y</p:attrName>
-                                        </p:attrNameLst>
-                                      </p:cBhvr>
-                                      <p:rCtr x="0" y="1759"/>
-                                    </p:animMotion>
-                                  </p:childTnLst>
-                                </p:cTn>
-                              </p:par>
-                              <p:par>
-                                <p:cTn id="125" presetID="10" presetClass="entr" presetSubtype="0" fill="hold" grpId="0" nodeType="withEffect">
-                                  <p:stCondLst>
-                                    <p:cond delay="100"/>
-                                  </p:stCondLst>
-                                  <p:childTnLst>
-                                    <p:set>
-                                      <p:cBhvr>
-                                        <p:cTn id="126" dur="1" fill="hold">
-                                          <p:stCondLst>
-                                            <p:cond delay="0"/>
-                                          </p:stCondLst>
-                                        </p:cTn>
-                                        <p:tgtEl>
-                                          <p:spTgt spid="204"/>
-                                        </p:tgtEl>
-                                        <p:attrNameLst>
-                                          <p:attrName>style.visibility</p:attrName>
-                                        </p:attrNameLst>
-                                      </p:cBhvr>
-                                      <p:to>
-                                        <p:strVal val="visible"/>
-                                      </p:to>
-                                    </p:set>
-                                    <p:animEffect transition="in" filter="fade">
-                                      <p:cBhvr>
-                                        <p:cTn id="127" dur="500"/>
-                                        <p:tgtEl>
-                                          <p:spTgt spid="204"/>
-                                        </p:tgtEl>
-                                      </p:cBhvr>
-                                    </p:animEffect>
-                                  </p:childTnLst>
-                                </p:cTn>
-                              </p:par>
-                              <p:par>
-                                <p:cTn id="128" presetID="42" presetClass="path" presetSubtype="0" decel="100000" fill="hold" grpId="1" nodeType="withEffect">
-                                  <p:stCondLst>
-                                    <p:cond delay="100"/>
-                                  </p:stCondLst>
-                                  <p:childTnLst>
-                                    <p:animMotion origin="layout" path="M 2.08333E-7 1.48148E-6 L 2.08333E-7 0.03542 " pathEditMode="relative" rAng="0" ptsTypes="AA">
-                                      <p:cBhvr>
-                                        <p:cTn id="129" dur="700" spd="-100000" fill="hold"/>
-                                        <p:tgtEl>
-                                          <p:spTgt spid="204"/>
-                                        </p:tgtEl>
-                                        <p:attrNameLst>
-                                          <p:attrName>ppt_x</p:attrName>
-                                          <p:attrName>ppt_y</p:attrName>
-                                        </p:attrNameLst>
-                                      </p:cBhvr>
-                                      <p:rCtr x="0" y="1759"/>
-                                    </p:animMotion>
-                                  </p:childTnLst>
-                                </p:cTn>
-                              </p:par>
-                            </p:childTnLst>
-                          </p:cTn>
-                        </p:par>
-                      </p:childTnLst>
-                    </p:cTn>
-                  </p:par>
-                </p:childTnLst>
-              </p:cTn>
-              <p:prevCondLst>
-                <p:cond evt="onPrev" delay="0">
-                  <p:tgtEl>
-                    <p:sldTgt/>
-                  </p:tgtEl>
-                </p:cond>
-              </p:prevCondLst>
-              <p:nextCondLst>
-                <p:cond evt="onNext" delay="0">
-                  <p:tgtEl>
-                    <p:sldTgt/>
-                  </p:tgtEl>
-                </p:cond>
-              </p:nextCondLst>
-            </p:seq>
-          </p:childTnLst>
-        </p:cTn>
-      </p:par>
-    </p:tnLst>
-    <p:bldLst>
-      <p:bldP spid="7" grpId="0" animBg="1"/>
-      <p:bldP spid="7" grpId="1" animBg="1"/>
-      <p:bldP spid="38" grpId="0" animBg="1"/>
-      <p:bldP spid="38" grpId="1" animBg="1"/>
-      <p:bldP spid="4" grpId="0" animBg="1"/>
-      <p:bldP spid="4" grpId="1" animBg="1"/>
-      <p:bldP spid="39" grpId="0" animBg="1"/>
-      <p:bldP spid="39" grpId="1" animBg="1"/>
-      <p:bldP spid="40" grpId="0" animBg="1"/>
-      <p:bldP spid="40" grpId="1" animBg="1"/>
-      <p:bldP spid="10" grpId="0"/>
-      <p:bldP spid="10" grpId="1"/>
-      <p:bldP spid="12" grpId="0"/>
-      <p:bldP spid="12" grpId="1"/>
-      <p:bldP spid="15" grpId="0"/>
-      <p:bldP spid="15" grpId="1"/>
-      <p:bldP spid="18" grpId="0"/>
-      <p:bldP spid="18" grpId="1"/>
-      <p:bldP spid="203" grpId="0" animBg="1"/>
-      <p:bldP spid="203" grpId="1" animBg="1"/>
-      <p:bldP spid="204" grpId="0" animBg="1"/>
-      <p:bldP spid="204" grpId="1" animBg="1"/>
-    </p:bldLst>
-  </p:timing>
 </p:sld>
 </file>
 

</xml_diff>